<commit_message>
Fix stale FRD/NFRD version numbers on proposal slides
Slides 5 and 6 footers still referenced FRD v1.6 / NFRD v1.5 after
this session's doc refresh bumped them to v1.7 / v1.6.
</commit_message>
<xml_diff>
--- a/docs/Project_Proposal.pptx
+++ b/docs/Project_Proposal.pptx
@@ -11025,7 +11025,7 @@
                   <a:srgbClr val="555555"/>
                 </a:solidFill>
               </a:rPr>
-              <a:t>Full detail: Functional Requirements Document (FRD) v1.6 · CleanCAD</a:t>
+              <a:t>Full detail: Functional Requirements Document (FRD) v1.7 · CleanCAD</a:t>
             </a:r>
           </a:p>
         </p:txBody>
@@ -11717,7 +11717,7 @@
                   <a:srgbClr val="555555"/>
                 </a:solidFill>
               </a:rPr>
-              <a:t>Full detail: Non-Functional Requirements Document (NFRD) v1.5 · CleanCAD</a:t>
+              <a:t>Full detail: Non-Functional Requirements Document (NFRD) v1.6 · CleanCAD</a:t>
             </a:r>
           </a:p>
         </p:txBody>

</xml_diff>

<commit_message>
Update proposal slide layouts (slides 9 and 14) as used in the presentation
Text is unchanged; only shape geometry on the design-alternatives table
and the risk cards differs from the previous commit.
</commit_message>
<xml_diff>
--- a/docs/Project_Proposal.pptx
+++ b/docs/Project_Proposal.pptx
@@ -4,26 +4,29 @@
   <p:sldMasterIdLst>
     <p:sldMasterId id="2147483648" r:id="rId1"/>
   </p:sldMasterIdLst>
+  <p:notesMasterIdLst>
+    <p:notesMasterId r:id="rId19"/>
+  </p:notesMasterIdLst>
   <p:sldIdLst>
-    <p:sldId id="256" r:id="rId7"/>
-    <p:sldId id="257" r:id="rId9"/>
-    <p:sldId id="258" r:id="rId10"/>
-    <p:sldId id="259" r:id="rId11"/>
-    <p:sldId id="260" r:id="rId12"/>
-    <p:sldId id="261" r:id="rId13"/>
-    <p:sldId id="262" r:id="rId14"/>
-    <p:sldId id="263" r:id="rId15"/>
-    <p:sldId id="264" r:id="rId16"/>
-    <p:sldId id="265" r:id="rId17"/>
-    <p:sldId id="266" r:id="rId18"/>
-    <p:sldId id="267" r:id="rId19"/>
-    <p:sldId id="268" r:id="rId20"/>
-    <p:sldId id="269" r:id="rId21"/>
-    <p:sldId id="270" r:id="rId22"/>
-    <p:sldId id="271" r:id="rId23"/>
-    <p:sldId id="272" r:id="rId24"/>
+    <p:sldId id="256" r:id="rId2"/>
+    <p:sldId id="257" r:id="rId3"/>
+    <p:sldId id="258" r:id="rId4"/>
+    <p:sldId id="259" r:id="rId5"/>
+    <p:sldId id="260" r:id="rId6"/>
+    <p:sldId id="261" r:id="rId7"/>
+    <p:sldId id="262" r:id="rId8"/>
+    <p:sldId id="263" r:id="rId9"/>
+    <p:sldId id="264" r:id="rId10"/>
+    <p:sldId id="265" r:id="rId11"/>
+    <p:sldId id="266" r:id="rId12"/>
+    <p:sldId id="267" r:id="rId13"/>
+    <p:sldId id="268" r:id="rId14"/>
+    <p:sldId id="269" r:id="rId15"/>
+    <p:sldId id="270" r:id="rId16"/>
+    <p:sldId id="271" r:id="rId17"/>
+    <p:sldId id="272" r:id="rId18"/>
   </p:sldIdLst>
-  <p:sldSz cx="12191695" cy="6858000" type="screen4x3"/>
+  <p:sldSz cx="12192000" cy="6858000"/>
   <p:notesSz cx="6858000" cy="9144000"/>
   <p:defaultTextStyle>
     <a:defPPr>
@@ -120,11 +123,27 @@
       </a:defRPr>
     </a:lvl9pPr>
   </p:defaultTextStyle>
+  <p:extLst>
+    <p:ext uri="{EFAFB233-063F-42B5-8137-9DF3F51BA10A}">
+      <p15:sldGuideLst xmlns:p15="http://schemas.microsoft.com/office/powerpoint/2012/main">
+        <p15:guide id="1" orient="horz" pos="2160">
+          <p15:clr>
+            <a:srgbClr val="A4A3A4"/>
+          </p15:clr>
+        </p15:guide>
+        <p15:guide id="2" pos="2880">
+          <p15:clr>
+            <a:srgbClr val="A4A3A4"/>
+          </p15:clr>
+        </p15:guide>
+      </p15:sldGuideLst>
+    </p:ext>
+  </p:extLst>
 </p:presentation>
 </file>
 
 <file path=ppt/notesMasters/notesMaster1.xml><?xml version="1.0" encoding="utf-8"?>
-<p:notesMaster xmlns:a="http://schemas.openxmlformats.org/drawingml/2006/main" xmlns:p="http://schemas.openxmlformats.org/presentationml/2006/main" xmlns:r="http://schemas.openxmlformats.org/officeDocument/2006/relationships">
+<p:notesMaster xmlns:a="http://schemas.openxmlformats.org/drawingml/2006/main" xmlns:r="http://schemas.openxmlformats.org/officeDocument/2006/relationships" xmlns:p="http://schemas.openxmlformats.org/presentationml/2006/main">
   <p:cSld>
     <p:bg>
       <p:bgRef idx="1001">
@@ -145,241 +164,16 @@
           <a:chExt cx="0" cy="0"/>
         </a:xfrm>
       </p:grpSpPr>
-      <p:sp>
-        <p:nvSpPr>
-          <p:cNvPr id="2" name="Header Placeholder 1"/>
-          <p:cNvSpPr>
-            <a:spLocks noGrp="1"/>
-          </p:cNvSpPr>
-          <p:nvPr>
-            <p:ph type="hdr" sz="quarter"/>
-          </p:nvPr>
-        </p:nvSpPr>
-        <p:spPr>
-          <a:xfrm>
-            <a:off x="0" y="0"/>
-            <a:ext cx="2971800" cy="457200"/>
-          </a:xfrm>
-          <a:prstGeom prst="rect">
-            <a:avLst/>
-          </a:prstGeom>
-        </p:spPr>
-        <p:txBody>
-          <a:bodyPr vert="horz" lIns="91440" tIns="45720" rIns="91440" bIns="45720" rtlCol="0"/>
-          <a:lstStyle>
-            <a:lvl1pPr algn="l">
-              <a:defRPr sz="1200"/>
-            </a:lvl1pPr>
-          </a:lstStyle>
-          <a:p>
-            <a:endParaRPr lang="en-US"/>
-          </a:p>
-        </p:txBody>
-      </p:sp>
-      <p:sp>
-        <p:nvSpPr>
-          <p:cNvPr id="3" name="Date Placeholder 2"/>
-          <p:cNvSpPr>
-            <a:spLocks noGrp="1"/>
-          </p:cNvSpPr>
-          <p:nvPr>
-            <p:ph type="dt" idx="1"/>
-          </p:nvPr>
-        </p:nvSpPr>
-        <p:spPr>
-          <a:xfrm>
-            <a:off x="3884613" y="0"/>
-            <a:ext cx="2971800" cy="457200"/>
-          </a:xfrm>
-          <a:prstGeom prst="rect">
-            <a:avLst/>
-          </a:prstGeom>
-        </p:spPr>
-        <p:txBody>
-          <a:bodyPr vert="horz" lIns="91440" tIns="45720" rIns="91440" bIns="45720" rtlCol="0"/>
-          <a:lstStyle>
-            <a:lvl1pPr algn="r">
-              <a:defRPr sz="1200"/>
-            </a:lvl1pPr>
-          </a:lstStyle>
-          <a:p>
-            <a:fld id="{0F89C1C7-3DCD-1040-A9CF-14679D8B5DDD}" type="datetimeFigureOut">
-              <a:rPr lang="en-US" smtClean="0"/>
-              <a:t>10/17/16</a:t>
-            </a:fld>
-            <a:endParaRPr lang="en-US"/>
-          </a:p>
-        </p:txBody>
-      </p:sp>
-      <p:sp>
-        <p:nvSpPr>
-          <p:cNvPr id="4" name="Slide Image Placeholder 3"/>
-          <p:cNvSpPr>
-            <a:spLocks noGrp="1" noRot="1" noChangeAspect="1"/>
-          </p:cNvSpPr>
-          <p:nvPr>
-            <p:ph type="sldImg" idx="2"/>
-          </p:nvPr>
-        </p:nvSpPr>
-        <p:spPr>
-          <a:xfrm>
-            <a:off x="1143000" y="685800"/>
-            <a:ext cx="4572000" cy="3429000"/>
-          </a:xfrm>
-          <a:prstGeom prst="rect">
-            <a:avLst/>
-          </a:prstGeom>
-          <a:noFill/>
-          <a:ln w="12700">
-            <a:solidFill>
-              <a:prstClr val="black"/>
-            </a:solidFill>
-          </a:ln>
-        </p:spPr>
-        <p:txBody>
-          <a:bodyPr vert="horz" lIns="91440" tIns="45720" rIns="91440" bIns="45720" rtlCol="0" anchor="ctr"/>
-          <a:lstStyle/>
-          <a:p>
-            <a:endParaRPr lang="en-US"/>
-          </a:p>
-        </p:txBody>
-      </p:sp>
-      <p:sp>
-        <p:nvSpPr>
-          <p:cNvPr id="5" name="Notes Placeholder 4"/>
-          <p:cNvSpPr>
-            <a:spLocks noGrp="1"/>
-          </p:cNvSpPr>
-          <p:nvPr>
-            <p:ph type="body" sz="quarter" idx="3"/>
-          </p:nvPr>
-        </p:nvSpPr>
-        <p:spPr>
-          <a:xfrm>
-            <a:off x="685800" y="4343400"/>
-            <a:ext cx="5486400" cy="4114800"/>
-          </a:xfrm>
-          <a:prstGeom prst="rect">
-            <a:avLst/>
-          </a:prstGeom>
-        </p:spPr>
-        <p:txBody>
-          <a:bodyPr vert="horz" lIns="91440" tIns="45720" rIns="91440" bIns="45720" rtlCol="0"/>
-          <a:lstStyle/>
-          <a:p>
-            <a:pPr lvl="0"/>
-            <a:r>
-              <a:rPr lang="en-US" smtClean="0"/>
-              <a:t>Click to edit Master text styles</a:t>
-            </a:r>
-          </a:p>
-          <a:p>
-            <a:pPr lvl="1"/>
-            <a:r>
-              <a:rPr lang="en-US" smtClean="0"/>
-              <a:t>Second level</a:t>
-            </a:r>
-          </a:p>
-          <a:p>
-            <a:pPr lvl="2"/>
-            <a:r>
-              <a:rPr lang="en-US" smtClean="0"/>
-              <a:t>Third level</a:t>
-            </a:r>
-          </a:p>
-          <a:p>
-            <a:pPr lvl="3"/>
-            <a:r>
-              <a:rPr lang="en-US" smtClean="0"/>
-              <a:t>Fourth level</a:t>
-            </a:r>
-          </a:p>
-          <a:p>
-            <a:pPr lvl="4"/>
-            <a:r>
-              <a:rPr lang="en-US" smtClean="0"/>
-              <a:t>Fifth level</a:t>
-            </a:r>
-            <a:endParaRPr lang="en-US"/>
-          </a:p>
-        </p:txBody>
-      </p:sp>
-      <p:sp>
-        <p:nvSpPr>
-          <p:cNvPr id="6" name="Footer Placeholder 5"/>
-          <p:cNvSpPr>
-            <a:spLocks noGrp="1"/>
-          </p:cNvSpPr>
-          <p:nvPr>
-            <p:ph type="ftr" sz="quarter" idx="4"/>
-          </p:nvPr>
-        </p:nvSpPr>
-        <p:spPr>
-          <a:xfrm>
-            <a:off x="0" y="8685213"/>
-            <a:ext cx="2971800" cy="457200"/>
-          </a:xfrm>
-          <a:prstGeom prst="rect">
-            <a:avLst/>
-          </a:prstGeom>
-        </p:spPr>
-        <p:txBody>
-          <a:bodyPr vert="horz" lIns="91440" tIns="45720" rIns="91440" bIns="45720" rtlCol="0" anchor="b"/>
-          <a:lstStyle>
-            <a:lvl1pPr algn="l">
-              <a:defRPr sz="1200"/>
-            </a:lvl1pPr>
-          </a:lstStyle>
-          <a:p>
-            <a:endParaRPr lang="en-US"/>
-          </a:p>
-        </p:txBody>
-      </p:sp>
-      <p:sp>
-        <p:nvSpPr>
-          <p:cNvPr id="7" name="Slide Number Placeholder 6"/>
-          <p:cNvSpPr>
-            <a:spLocks noGrp="1"/>
-          </p:cNvSpPr>
-          <p:nvPr>
-            <p:ph type="sldNum" sz="quarter" idx="5"/>
-          </p:nvPr>
-        </p:nvSpPr>
-        <p:spPr>
-          <a:xfrm>
-            <a:off x="3884613" y="8685213"/>
-            <a:ext cx="2971800" cy="457200"/>
-          </a:xfrm>
-          <a:prstGeom prst="rect">
-            <a:avLst/>
-          </a:prstGeom>
-        </p:spPr>
-        <p:txBody>
-          <a:bodyPr vert="horz" lIns="91440" tIns="45720" rIns="91440" bIns="45720" rtlCol="0" anchor="b"/>
-          <a:lstStyle>
-            <a:lvl1pPr algn="r">
-              <a:defRPr sz="1200"/>
-            </a:lvl1pPr>
-          </a:lstStyle>
-          <a:p>
-            <a:fld id="{BB5E49A5-4136-284D-997B-48E1D791AD67}" type="slidenum">
-              <a:rPr lang="en-US" smtClean="0"/>
-              <a:t>‹#›</a:t>
-            </a:fld>
-            <a:endParaRPr lang="en-US"/>
-          </a:p>
-        </p:txBody>
-      </p:sp>
     </p:spTree>
     <p:extLst>
       <p:ext uri="{BB962C8B-B14F-4D97-AF65-F5344CB8AC3E}">
-        <p14:creationId xmlns:p14="http://schemas.microsoft.com/office/powerpoint/2010/main" val="2623252185"/>
+        <p14:creationId xmlns:p14="http://schemas.microsoft.com/office/powerpoint/2010/main" val="2200537464"/>
       </p:ext>
     </p:extLst>
   </p:cSld>
   <p:clrMap bg1="lt1" tx1="dk1" bg2="lt2" tx2="dk2" accent1="accent1" accent2="accent2" accent3="accent3" accent4="accent4" accent5="accent5" accent6="accent6" hlink="hlink" folHlink="folHlink"/>
   <p:notesStyle>
-    <a:lvl1pPr marL="0" algn="l" defTabSz="457200" rtl="0" eaLnBrk="1" latinLnBrk="0" hangingPunct="1">
+    <a:lvl1pPr marL="0" algn="l" defTabSz="914400" rtl="0" eaLnBrk="1" latinLnBrk="1" hangingPunct="1">
       <a:defRPr sz="1200" kern="1200">
         <a:solidFill>
           <a:schemeClr val="tx1"/>
@@ -389,7 +183,7 @@
         <a:cs typeface="+mn-cs"/>
       </a:defRPr>
     </a:lvl1pPr>
-    <a:lvl2pPr marL="457200" algn="l" defTabSz="457200" rtl="0" eaLnBrk="1" latinLnBrk="0" hangingPunct="1">
+    <a:lvl2pPr marL="457200" algn="l" defTabSz="914400" rtl="0" eaLnBrk="1" latinLnBrk="1" hangingPunct="1">
       <a:defRPr sz="1200" kern="1200">
         <a:solidFill>
           <a:schemeClr val="tx1"/>
@@ -399,7 +193,7 @@
         <a:cs typeface="+mn-cs"/>
       </a:defRPr>
     </a:lvl2pPr>
-    <a:lvl3pPr marL="914400" algn="l" defTabSz="457200" rtl="0" eaLnBrk="1" latinLnBrk="0" hangingPunct="1">
+    <a:lvl3pPr marL="914400" algn="l" defTabSz="914400" rtl="0" eaLnBrk="1" latinLnBrk="1" hangingPunct="1">
       <a:defRPr sz="1200" kern="1200">
         <a:solidFill>
           <a:schemeClr val="tx1"/>
@@ -409,7 +203,7 @@
         <a:cs typeface="+mn-cs"/>
       </a:defRPr>
     </a:lvl3pPr>
-    <a:lvl4pPr marL="1371600" algn="l" defTabSz="457200" rtl="0" eaLnBrk="1" latinLnBrk="0" hangingPunct="1">
+    <a:lvl4pPr marL="1371600" algn="l" defTabSz="914400" rtl="0" eaLnBrk="1" latinLnBrk="1" hangingPunct="1">
       <a:defRPr sz="1200" kern="1200">
         <a:solidFill>
           <a:schemeClr val="tx1"/>
@@ -419,7 +213,7 @@
         <a:cs typeface="+mn-cs"/>
       </a:defRPr>
     </a:lvl4pPr>
-    <a:lvl5pPr marL="1828800" algn="l" defTabSz="457200" rtl="0" eaLnBrk="1" latinLnBrk="0" hangingPunct="1">
+    <a:lvl5pPr marL="1828800" algn="l" defTabSz="914400" rtl="0" eaLnBrk="1" latinLnBrk="1" hangingPunct="1">
       <a:defRPr sz="1200" kern="1200">
         <a:solidFill>
           <a:schemeClr val="tx1"/>
@@ -429,7 +223,7 @@
         <a:cs typeface="+mn-cs"/>
       </a:defRPr>
     </a:lvl5pPr>
-    <a:lvl6pPr marL="2286000" algn="l" defTabSz="457200" rtl="0" eaLnBrk="1" latinLnBrk="0" hangingPunct="1">
+    <a:lvl6pPr marL="2286000" algn="l" defTabSz="914400" rtl="0" eaLnBrk="1" latinLnBrk="1" hangingPunct="1">
       <a:defRPr sz="1200" kern="1200">
         <a:solidFill>
           <a:schemeClr val="tx1"/>
@@ -439,7 +233,7 @@
         <a:cs typeface="+mn-cs"/>
       </a:defRPr>
     </a:lvl6pPr>
-    <a:lvl7pPr marL="2743200" algn="l" defTabSz="457200" rtl="0" eaLnBrk="1" latinLnBrk="0" hangingPunct="1">
+    <a:lvl7pPr marL="2743200" algn="l" defTabSz="914400" rtl="0" eaLnBrk="1" latinLnBrk="1" hangingPunct="1">
       <a:defRPr sz="1200" kern="1200">
         <a:solidFill>
           <a:schemeClr val="tx1"/>
@@ -449,7 +243,7 @@
         <a:cs typeface="+mn-cs"/>
       </a:defRPr>
     </a:lvl7pPr>
-    <a:lvl8pPr marL="3200400" algn="l" defTabSz="457200" rtl="0" eaLnBrk="1" latinLnBrk="0" hangingPunct="1">
+    <a:lvl8pPr marL="3200400" algn="l" defTabSz="914400" rtl="0" eaLnBrk="1" latinLnBrk="1" hangingPunct="1">
       <a:defRPr sz="1200" kern="1200">
         <a:solidFill>
           <a:schemeClr val="tx1"/>
@@ -459,7 +253,7 @@
         <a:cs typeface="+mn-cs"/>
       </a:defRPr>
     </a:lvl8pPr>
-    <a:lvl9pPr marL="3657600" algn="l" defTabSz="457200" rtl="0" eaLnBrk="1" latinLnBrk="0" hangingPunct="1">
+    <a:lvl9pPr marL="3657600" algn="l" defTabSz="914400" rtl="0" eaLnBrk="1" latinLnBrk="1" hangingPunct="1">
       <a:defRPr sz="1200" kern="1200">
         <a:solidFill>
           <a:schemeClr val="tx1"/>
@@ -474,7 +268,7 @@
 </file>
 
 <file path=ppt/notesSlides/notesSlide1.xml><?xml version="1.0" encoding="utf-8"?>
-<p:notes xmlns:a="http://schemas.openxmlformats.org/drawingml/2006/main" xmlns:p="http://schemas.openxmlformats.org/presentationml/2006/main" xmlns:r="http://schemas.openxmlformats.org/officeDocument/2006/relationships">
+<p:notes xmlns:a="http://schemas.openxmlformats.org/drawingml/2006/main" xmlns:r="http://schemas.openxmlformats.org/officeDocument/2006/relationships" xmlns:p="http://schemas.openxmlformats.org/presentationml/2006/main">
   <p:cSld>
     <p:spTree>
       <p:nvGrpSpPr>
@@ -494,7 +288,7 @@
         <p:nvSpPr>
           <p:cNvPr id="2" name="Slide Image Placeholder 1"/>
           <p:cNvSpPr>
-            <a:spLocks noGrp="1"/>
+            <a:spLocks noGrp="1" noRot="1" noChangeAspect="1"/>
           </p:cNvSpPr>
           <p:nvPr>
             <p:ph type="sldImg" idx="2"/>
@@ -509,7 +303,7 @@
             <a:spLocks noGrp="1"/>
           </p:cNvSpPr>
           <p:nvPr>
-            <p:ph type="body" idx="3" sz="quarter"/>
+            <p:ph type="body" sz="quarter" idx="3"/>
           </p:nvPr>
         </p:nvSpPr>
         <p:spPr/>
@@ -530,7 +324,7 @@
             <a:spLocks noGrp="1"/>
           </p:cNvSpPr>
           <p:nvPr>
-            <p:ph type="sldNum" idx="5" sz="quarter"/>
+            <p:ph type="sldNum" sz="quarter" idx="5"/>
           </p:nvPr>
         </p:nvSpPr>
         <p:spPr/>
@@ -544,7 +338,7 @@
 </file>
 
 <file path=ppt/notesSlides/notesSlide10.xml><?xml version="1.0" encoding="utf-8"?>
-<p:notes xmlns:a="http://schemas.openxmlformats.org/drawingml/2006/main" xmlns:p="http://schemas.openxmlformats.org/presentationml/2006/main" xmlns:r="http://schemas.openxmlformats.org/officeDocument/2006/relationships">
+<p:notes xmlns:a="http://schemas.openxmlformats.org/drawingml/2006/main" xmlns:r="http://schemas.openxmlformats.org/officeDocument/2006/relationships" xmlns:p="http://schemas.openxmlformats.org/presentationml/2006/main">
   <p:cSld>
     <p:spTree>
       <p:nvGrpSpPr>
@@ -564,7 +358,7 @@
         <p:nvSpPr>
           <p:cNvPr id="2" name="Slide Image Placeholder 1"/>
           <p:cNvSpPr>
-            <a:spLocks noGrp="1"/>
+            <a:spLocks noGrp="1" noRot="1" noChangeAspect="1"/>
           </p:cNvSpPr>
           <p:nvPr>
             <p:ph type="sldImg" idx="2"/>
@@ -579,7 +373,7 @@
             <a:spLocks noGrp="1"/>
           </p:cNvSpPr>
           <p:nvPr>
-            <p:ph type="body" idx="3" sz="quarter"/>
+            <p:ph type="body" sz="quarter" idx="3"/>
           </p:nvPr>
         </p:nvSpPr>
         <p:spPr/>
@@ -600,7 +394,7 @@
             <a:spLocks noGrp="1"/>
           </p:cNvSpPr>
           <p:nvPr>
-            <p:ph type="sldNum" idx="5" sz="quarter"/>
+            <p:ph type="sldNum" sz="quarter" idx="5"/>
           </p:nvPr>
         </p:nvSpPr>
         <p:spPr/>
@@ -614,7 +408,7 @@
 </file>
 
 <file path=ppt/notesSlides/notesSlide11.xml><?xml version="1.0" encoding="utf-8"?>
-<p:notes xmlns:a="http://schemas.openxmlformats.org/drawingml/2006/main" xmlns:p="http://schemas.openxmlformats.org/presentationml/2006/main" xmlns:r="http://schemas.openxmlformats.org/officeDocument/2006/relationships">
+<p:notes xmlns:a="http://schemas.openxmlformats.org/drawingml/2006/main" xmlns:r="http://schemas.openxmlformats.org/officeDocument/2006/relationships" xmlns:p="http://schemas.openxmlformats.org/presentationml/2006/main">
   <p:cSld>
     <p:spTree>
       <p:nvGrpSpPr>
@@ -634,7 +428,7 @@
         <p:nvSpPr>
           <p:cNvPr id="2" name="Slide Image Placeholder 1"/>
           <p:cNvSpPr>
-            <a:spLocks noGrp="1"/>
+            <a:spLocks noGrp="1" noRot="1" noChangeAspect="1"/>
           </p:cNvSpPr>
           <p:nvPr>
             <p:ph type="sldImg" idx="2"/>
@@ -649,7 +443,7 @@
             <a:spLocks noGrp="1"/>
           </p:cNvSpPr>
           <p:nvPr>
-            <p:ph type="body" idx="3" sz="quarter"/>
+            <p:ph type="body" sz="quarter" idx="3"/>
           </p:nvPr>
         </p:nvSpPr>
         <p:spPr/>
@@ -670,7 +464,7 @@
             <a:spLocks noGrp="1"/>
           </p:cNvSpPr>
           <p:nvPr>
-            <p:ph type="sldNum" idx="5" sz="quarter"/>
+            <p:ph type="sldNum" sz="quarter" idx="5"/>
           </p:nvPr>
         </p:nvSpPr>
         <p:spPr/>
@@ -684,7 +478,7 @@
 </file>
 
 <file path=ppt/notesSlides/notesSlide12.xml><?xml version="1.0" encoding="utf-8"?>
-<p:notes xmlns:a="http://schemas.openxmlformats.org/drawingml/2006/main" xmlns:p="http://schemas.openxmlformats.org/presentationml/2006/main" xmlns:r="http://schemas.openxmlformats.org/officeDocument/2006/relationships">
+<p:notes xmlns:a="http://schemas.openxmlformats.org/drawingml/2006/main" xmlns:r="http://schemas.openxmlformats.org/officeDocument/2006/relationships" xmlns:p="http://schemas.openxmlformats.org/presentationml/2006/main">
   <p:cSld>
     <p:spTree>
       <p:nvGrpSpPr>
@@ -704,7 +498,7 @@
         <p:nvSpPr>
           <p:cNvPr id="2" name="Slide Image Placeholder 1"/>
           <p:cNvSpPr>
-            <a:spLocks noGrp="1"/>
+            <a:spLocks noGrp="1" noRot="1" noChangeAspect="1"/>
           </p:cNvSpPr>
           <p:nvPr>
             <p:ph type="sldImg" idx="2"/>
@@ -719,7 +513,7 @@
             <a:spLocks noGrp="1"/>
           </p:cNvSpPr>
           <p:nvPr>
-            <p:ph type="body" idx="3" sz="quarter"/>
+            <p:ph type="body" sz="quarter" idx="3"/>
           </p:nvPr>
         </p:nvSpPr>
         <p:spPr/>
@@ -740,7 +534,7 @@
             <a:spLocks noGrp="1"/>
           </p:cNvSpPr>
           <p:nvPr>
-            <p:ph type="sldNum" idx="5" sz="quarter"/>
+            <p:ph type="sldNum" sz="quarter" idx="5"/>
           </p:nvPr>
         </p:nvSpPr>
         <p:spPr/>
@@ -754,7 +548,7 @@
 </file>
 
 <file path=ppt/notesSlides/notesSlide13.xml><?xml version="1.0" encoding="utf-8"?>
-<p:notes xmlns:a="http://schemas.openxmlformats.org/drawingml/2006/main" xmlns:p="http://schemas.openxmlformats.org/presentationml/2006/main" xmlns:r="http://schemas.openxmlformats.org/officeDocument/2006/relationships">
+<p:notes xmlns:a="http://schemas.openxmlformats.org/drawingml/2006/main" xmlns:r="http://schemas.openxmlformats.org/officeDocument/2006/relationships" xmlns:p="http://schemas.openxmlformats.org/presentationml/2006/main">
   <p:cSld>
     <p:spTree>
       <p:nvGrpSpPr>
@@ -774,7 +568,7 @@
         <p:nvSpPr>
           <p:cNvPr id="2" name="Slide Image Placeholder 1"/>
           <p:cNvSpPr>
-            <a:spLocks noGrp="1"/>
+            <a:spLocks noGrp="1" noRot="1" noChangeAspect="1"/>
           </p:cNvSpPr>
           <p:nvPr>
             <p:ph type="sldImg" idx="2"/>
@@ -789,7 +583,7 @@
             <a:spLocks noGrp="1"/>
           </p:cNvSpPr>
           <p:nvPr>
-            <p:ph type="body" idx="3" sz="quarter"/>
+            <p:ph type="body" sz="quarter" idx="3"/>
           </p:nvPr>
         </p:nvSpPr>
         <p:spPr/>
@@ -810,7 +604,7 @@
             <a:spLocks noGrp="1"/>
           </p:cNvSpPr>
           <p:nvPr>
-            <p:ph type="sldNum" idx="5" sz="quarter"/>
+            <p:ph type="sldNum" sz="quarter" idx="5"/>
           </p:nvPr>
         </p:nvSpPr>
         <p:spPr/>
@@ -824,7 +618,7 @@
 </file>
 
 <file path=ppt/notesSlides/notesSlide14.xml><?xml version="1.0" encoding="utf-8"?>
-<p:notes xmlns:a="http://schemas.openxmlformats.org/drawingml/2006/main" xmlns:p="http://schemas.openxmlformats.org/presentationml/2006/main" xmlns:r="http://schemas.openxmlformats.org/officeDocument/2006/relationships">
+<p:notes xmlns:a="http://schemas.openxmlformats.org/drawingml/2006/main" xmlns:r="http://schemas.openxmlformats.org/officeDocument/2006/relationships" xmlns:p="http://schemas.openxmlformats.org/presentationml/2006/main">
   <p:cSld>
     <p:spTree>
       <p:nvGrpSpPr>
@@ -844,7 +638,7 @@
         <p:nvSpPr>
           <p:cNvPr id="2" name="Slide Image Placeholder 1"/>
           <p:cNvSpPr>
-            <a:spLocks noGrp="1"/>
+            <a:spLocks noGrp="1" noRot="1" noChangeAspect="1"/>
           </p:cNvSpPr>
           <p:nvPr>
             <p:ph type="sldImg" idx="2"/>
@@ -859,7 +653,7 @@
             <a:spLocks noGrp="1"/>
           </p:cNvSpPr>
           <p:nvPr>
-            <p:ph type="body" idx="3" sz="quarter"/>
+            <p:ph type="body" sz="quarter" idx="3"/>
           </p:nvPr>
         </p:nvSpPr>
         <p:spPr/>
@@ -880,7 +674,7 @@
             <a:spLocks noGrp="1"/>
           </p:cNvSpPr>
           <p:nvPr>
-            <p:ph type="sldNum" idx="5" sz="quarter"/>
+            <p:ph type="sldNum" sz="quarter" idx="5"/>
           </p:nvPr>
         </p:nvSpPr>
         <p:spPr/>
@@ -894,7 +688,7 @@
 </file>
 
 <file path=ppt/notesSlides/notesSlide15.xml><?xml version="1.0" encoding="utf-8"?>
-<p:notes xmlns:a="http://schemas.openxmlformats.org/drawingml/2006/main" xmlns:p="http://schemas.openxmlformats.org/presentationml/2006/main" xmlns:r="http://schemas.openxmlformats.org/officeDocument/2006/relationships">
+<p:notes xmlns:a="http://schemas.openxmlformats.org/drawingml/2006/main" xmlns:r="http://schemas.openxmlformats.org/officeDocument/2006/relationships" xmlns:p="http://schemas.openxmlformats.org/presentationml/2006/main">
   <p:cSld>
     <p:spTree>
       <p:nvGrpSpPr>
@@ -914,7 +708,7 @@
         <p:nvSpPr>
           <p:cNvPr id="2" name="Slide Image Placeholder 1"/>
           <p:cNvSpPr>
-            <a:spLocks noGrp="1"/>
+            <a:spLocks noGrp="1" noRot="1" noChangeAspect="1"/>
           </p:cNvSpPr>
           <p:nvPr>
             <p:ph type="sldImg" idx="2"/>
@@ -929,7 +723,7 @@
             <a:spLocks noGrp="1"/>
           </p:cNvSpPr>
           <p:nvPr>
-            <p:ph type="body" idx="3" sz="quarter"/>
+            <p:ph type="body" sz="quarter" idx="3"/>
           </p:nvPr>
         </p:nvSpPr>
         <p:spPr/>
@@ -950,7 +744,7 @@
             <a:spLocks noGrp="1"/>
           </p:cNvSpPr>
           <p:nvPr>
-            <p:ph type="sldNum" idx="5" sz="quarter"/>
+            <p:ph type="sldNum" sz="quarter" idx="5"/>
           </p:nvPr>
         </p:nvSpPr>
         <p:spPr/>
@@ -964,7 +758,7 @@
 </file>
 
 <file path=ppt/notesSlides/notesSlide16.xml><?xml version="1.0" encoding="utf-8"?>
-<p:notes xmlns:a="http://schemas.openxmlformats.org/drawingml/2006/main" xmlns:p="http://schemas.openxmlformats.org/presentationml/2006/main" xmlns:r="http://schemas.openxmlformats.org/officeDocument/2006/relationships">
+<p:notes xmlns:a="http://schemas.openxmlformats.org/drawingml/2006/main" xmlns:r="http://schemas.openxmlformats.org/officeDocument/2006/relationships" xmlns:p="http://schemas.openxmlformats.org/presentationml/2006/main">
   <p:cSld>
     <p:spTree>
       <p:nvGrpSpPr>
@@ -984,7 +778,7 @@
         <p:nvSpPr>
           <p:cNvPr id="2" name="Slide Image Placeholder 1"/>
           <p:cNvSpPr>
-            <a:spLocks noGrp="1"/>
+            <a:spLocks noGrp="1" noRot="1" noChangeAspect="1"/>
           </p:cNvSpPr>
           <p:nvPr>
             <p:ph type="sldImg" idx="2"/>
@@ -999,7 +793,7 @@
             <a:spLocks noGrp="1"/>
           </p:cNvSpPr>
           <p:nvPr>
-            <p:ph type="body" idx="3" sz="quarter"/>
+            <p:ph type="body" sz="quarter" idx="3"/>
           </p:nvPr>
         </p:nvSpPr>
         <p:spPr/>
@@ -1020,7 +814,7 @@
             <a:spLocks noGrp="1"/>
           </p:cNvSpPr>
           <p:nvPr>
-            <p:ph type="sldNum" idx="5" sz="quarter"/>
+            <p:ph type="sldNum" sz="quarter" idx="5"/>
           </p:nvPr>
         </p:nvSpPr>
         <p:spPr/>
@@ -1034,7 +828,7 @@
 </file>
 
 <file path=ppt/notesSlides/notesSlide17.xml><?xml version="1.0" encoding="utf-8"?>
-<p:notes xmlns:a="http://schemas.openxmlformats.org/drawingml/2006/main" xmlns:p="http://schemas.openxmlformats.org/presentationml/2006/main" xmlns:r="http://schemas.openxmlformats.org/officeDocument/2006/relationships">
+<p:notes xmlns:a="http://schemas.openxmlformats.org/drawingml/2006/main" xmlns:r="http://schemas.openxmlformats.org/officeDocument/2006/relationships" xmlns:p="http://schemas.openxmlformats.org/presentationml/2006/main">
   <p:cSld>
     <p:spTree>
       <p:nvGrpSpPr>
@@ -1054,7 +848,7 @@
         <p:nvSpPr>
           <p:cNvPr id="2" name="Slide Image Placeholder 1"/>
           <p:cNvSpPr>
-            <a:spLocks noGrp="1"/>
+            <a:spLocks noGrp="1" noRot="1" noChangeAspect="1"/>
           </p:cNvSpPr>
           <p:nvPr>
             <p:ph type="sldImg" idx="2"/>
@@ -1069,7 +863,7 @@
             <a:spLocks noGrp="1"/>
           </p:cNvSpPr>
           <p:nvPr>
-            <p:ph type="body" idx="3" sz="quarter"/>
+            <p:ph type="body" sz="quarter" idx="3"/>
           </p:nvPr>
         </p:nvSpPr>
         <p:spPr/>
@@ -1078,7 +872,23 @@
           <a:lstStyle/>
           <a:p>
             <a:r>
-              <a:t>Four sub-roles, mapped directly to the four pipeline layers we described earlier. Junoh leads the team and owns the CAD geometry engineering — the shared mechanism everyone else builds on. Hemanth owns the ML and graph modeling side, including the constraint that inference has to run on a CPU. Aneela owns data — generating and labeling our own test shapes, and doing error analysis when the model gets something wrong. Elias owns integration and testing — the module contracts and automated verification that keep everyone's work compatible. Decisions go through the team lead, informed by mentor input where relevant, and all code changes go through a personal branch and review before merging.</a:t>
+              <a:t>Four sub-roles, mapped directly to the four pipeline layers we described earlier. </a:t>
+            </a:r>
+            <a:r>
+              <a:rPr dirty="0" err="1"/>
+              <a:t>Junoh</a:t>
+            </a:r>
+            <a:r>
+              <a:rPr dirty="0"/>
+              <a:t> leads the team and owns the CAD geometry engineering — the shared mechanism everyone else builds on. Hemanth owns the ML and graph modeling side, including the constraint that inference has to run on a CPU. </a:t>
+            </a:r>
+            <a:r>
+              <a:rPr dirty="0" err="1"/>
+              <a:t>Aneela</a:t>
+            </a:r>
+            <a:r>
+              <a:rPr dirty="0"/>
+              <a:t> owns data — generating and labeling our own test shapes, and doing error analysis when the model gets something wrong. Elias owns integration and testing — the module contracts and automated verification that keep everyone's work compatible. Decisions go through the team lead, informed by mentor input where relevant, and all code changes go through a personal branch and review before merging.</a:t>
             </a:r>
           </a:p>
         </p:txBody>
@@ -1090,7 +900,7 @@
             <a:spLocks noGrp="1"/>
           </p:cNvSpPr>
           <p:nvPr>
-            <p:ph type="sldNum" idx="5" sz="quarter"/>
+            <p:ph type="sldNum" sz="quarter" idx="5"/>
           </p:nvPr>
         </p:nvSpPr>
         <p:spPr/>
@@ -1104,7 +914,7 @@
 </file>
 
 <file path=ppt/notesSlides/notesSlide2.xml><?xml version="1.0" encoding="utf-8"?>
-<p:notes xmlns:a="http://schemas.openxmlformats.org/drawingml/2006/main" xmlns:p="http://schemas.openxmlformats.org/presentationml/2006/main" xmlns:r="http://schemas.openxmlformats.org/officeDocument/2006/relationships">
+<p:notes xmlns:a="http://schemas.openxmlformats.org/drawingml/2006/main" xmlns:r="http://schemas.openxmlformats.org/officeDocument/2006/relationships" xmlns:p="http://schemas.openxmlformats.org/presentationml/2006/main">
   <p:cSld>
     <p:spTree>
       <p:nvGrpSpPr>
@@ -1124,7 +934,7 @@
         <p:nvSpPr>
           <p:cNvPr id="2" name="Slide Image Placeholder 1"/>
           <p:cNvSpPr>
-            <a:spLocks noGrp="1"/>
+            <a:spLocks noGrp="1" noRot="1" noChangeAspect="1"/>
           </p:cNvSpPr>
           <p:nvPr>
             <p:ph type="sldImg" idx="2"/>
@@ -1139,7 +949,7 @@
             <a:spLocks noGrp="1"/>
           </p:cNvSpPr>
           <p:nvPr>
-            <p:ph type="body" idx="3" sz="quarter"/>
+            <p:ph type="body" sz="quarter" idx="3"/>
           </p:nvPr>
         </p:nvSpPr>
         <p:spPr/>
@@ -1160,7 +970,7 @@
             <a:spLocks noGrp="1"/>
           </p:cNvSpPr>
           <p:nvPr>
-            <p:ph type="sldNum" idx="5" sz="quarter"/>
+            <p:ph type="sldNum" sz="quarter" idx="5"/>
           </p:nvPr>
         </p:nvSpPr>
         <p:spPr/>
@@ -1174,7 +984,7 @@
 </file>
 
 <file path=ppt/notesSlides/notesSlide3.xml><?xml version="1.0" encoding="utf-8"?>
-<p:notes xmlns:a="http://schemas.openxmlformats.org/drawingml/2006/main" xmlns:p="http://schemas.openxmlformats.org/presentationml/2006/main" xmlns:r="http://schemas.openxmlformats.org/officeDocument/2006/relationships">
+<p:notes xmlns:a="http://schemas.openxmlformats.org/drawingml/2006/main" xmlns:r="http://schemas.openxmlformats.org/officeDocument/2006/relationships" xmlns:p="http://schemas.openxmlformats.org/presentationml/2006/main">
   <p:cSld>
     <p:spTree>
       <p:nvGrpSpPr>
@@ -1194,7 +1004,7 @@
         <p:nvSpPr>
           <p:cNvPr id="2" name="Slide Image Placeholder 1"/>
           <p:cNvSpPr>
-            <a:spLocks noGrp="1"/>
+            <a:spLocks noGrp="1" noRot="1" noChangeAspect="1"/>
           </p:cNvSpPr>
           <p:nvPr>
             <p:ph type="sldImg" idx="2"/>
@@ -1209,7 +1019,7 @@
             <a:spLocks noGrp="1"/>
           </p:cNvSpPr>
           <p:nvPr>
-            <p:ph type="body" idx="3" sz="quarter"/>
+            <p:ph type="body" sz="quarter" idx="3"/>
           </p:nvPr>
         </p:nvSpPr>
         <p:spPr/>
@@ -1230,7 +1040,7 @@
             <a:spLocks noGrp="1"/>
           </p:cNvSpPr>
           <p:nvPr>
-            <p:ph type="sldNum" idx="5" sz="quarter"/>
+            <p:ph type="sldNum" sz="quarter" idx="5"/>
           </p:nvPr>
         </p:nvSpPr>
         <p:spPr/>
@@ -1244,7 +1054,7 @@
 </file>
 
 <file path=ppt/notesSlides/notesSlide4.xml><?xml version="1.0" encoding="utf-8"?>
-<p:notes xmlns:a="http://schemas.openxmlformats.org/drawingml/2006/main" xmlns:p="http://schemas.openxmlformats.org/presentationml/2006/main" xmlns:r="http://schemas.openxmlformats.org/officeDocument/2006/relationships">
+<p:notes xmlns:a="http://schemas.openxmlformats.org/drawingml/2006/main" xmlns:r="http://schemas.openxmlformats.org/officeDocument/2006/relationships" xmlns:p="http://schemas.openxmlformats.org/presentationml/2006/main">
   <p:cSld>
     <p:spTree>
       <p:nvGrpSpPr>
@@ -1264,7 +1074,7 @@
         <p:nvSpPr>
           <p:cNvPr id="2" name="Slide Image Placeholder 1"/>
           <p:cNvSpPr>
-            <a:spLocks noGrp="1"/>
+            <a:spLocks noGrp="1" noRot="1" noChangeAspect="1"/>
           </p:cNvSpPr>
           <p:nvPr>
             <p:ph type="sldImg" idx="2"/>
@@ -1279,7 +1089,7 @@
             <a:spLocks noGrp="1"/>
           </p:cNvSpPr>
           <p:nvPr>
-            <p:ph type="body" idx="3" sz="quarter"/>
+            <p:ph type="body" sz="quarter" idx="3"/>
           </p:nvPr>
         </p:nvSpPr>
         <p:spPr/>
@@ -1300,7 +1110,7 @@
             <a:spLocks noGrp="1"/>
           </p:cNvSpPr>
           <p:nvPr>
-            <p:ph type="sldNum" idx="5" sz="quarter"/>
+            <p:ph type="sldNum" sz="quarter" idx="5"/>
           </p:nvPr>
         </p:nvSpPr>
         <p:spPr/>
@@ -1314,7 +1124,7 @@
 </file>
 
 <file path=ppt/notesSlides/notesSlide5.xml><?xml version="1.0" encoding="utf-8"?>
-<p:notes xmlns:a="http://schemas.openxmlformats.org/drawingml/2006/main" xmlns:p="http://schemas.openxmlformats.org/presentationml/2006/main" xmlns:r="http://schemas.openxmlformats.org/officeDocument/2006/relationships">
+<p:notes xmlns:a="http://schemas.openxmlformats.org/drawingml/2006/main" xmlns:r="http://schemas.openxmlformats.org/officeDocument/2006/relationships" xmlns:p="http://schemas.openxmlformats.org/presentationml/2006/main">
   <p:cSld>
     <p:spTree>
       <p:nvGrpSpPr>
@@ -1334,7 +1144,7 @@
         <p:nvSpPr>
           <p:cNvPr id="2" name="Slide Image Placeholder 1"/>
           <p:cNvSpPr>
-            <a:spLocks noGrp="1"/>
+            <a:spLocks noGrp="1" noRot="1" noChangeAspect="1"/>
           </p:cNvSpPr>
           <p:nvPr>
             <p:ph type="sldImg" idx="2"/>
@@ -1349,7 +1159,7 @@
             <a:spLocks noGrp="1"/>
           </p:cNvSpPr>
           <p:nvPr>
-            <p:ph type="body" idx="3" sz="quarter"/>
+            <p:ph type="body" sz="quarter" idx="3"/>
           </p:nvPr>
         </p:nvSpPr>
         <p:spPr/>
@@ -1370,7 +1180,7 @@
             <a:spLocks noGrp="1"/>
           </p:cNvSpPr>
           <p:nvPr>
-            <p:ph type="sldNum" idx="5" sz="quarter"/>
+            <p:ph type="sldNum" sz="quarter" idx="5"/>
           </p:nvPr>
         </p:nvSpPr>
         <p:spPr/>
@@ -1384,7 +1194,7 @@
 </file>
 
 <file path=ppt/notesSlides/notesSlide6.xml><?xml version="1.0" encoding="utf-8"?>
-<p:notes xmlns:a="http://schemas.openxmlformats.org/drawingml/2006/main" xmlns:p="http://schemas.openxmlformats.org/presentationml/2006/main" xmlns:r="http://schemas.openxmlformats.org/officeDocument/2006/relationships">
+<p:notes xmlns:a="http://schemas.openxmlformats.org/drawingml/2006/main" xmlns:r="http://schemas.openxmlformats.org/officeDocument/2006/relationships" xmlns:p="http://schemas.openxmlformats.org/presentationml/2006/main">
   <p:cSld>
     <p:spTree>
       <p:nvGrpSpPr>
@@ -1404,7 +1214,7 @@
         <p:nvSpPr>
           <p:cNvPr id="2" name="Slide Image Placeholder 1"/>
           <p:cNvSpPr>
-            <a:spLocks noGrp="1"/>
+            <a:spLocks noGrp="1" noRot="1" noChangeAspect="1"/>
           </p:cNvSpPr>
           <p:nvPr>
             <p:ph type="sldImg" idx="2"/>
@@ -1419,7 +1229,7 @@
             <a:spLocks noGrp="1"/>
           </p:cNvSpPr>
           <p:nvPr>
-            <p:ph type="body" idx="3" sz="quarter"/>
+            <p:ph type="body" sz="quarter" idx="3"/>
           </p:nvPr>
         </p:nvSpPr>
         <p:spPr/>
@@ -1440,7 +1250,7 @@
             <a:spLocks noGrp="1"/>
           </p:cNvSpPr>
           <p:nvPr>
-            <p:ph type="sldNum" idx="5" sz="quarter"/>
+            <p:ph type="sldNum" sz="quarter" idx="5"/>
           </p:nvPr>
         </p:nvSpPr>
         <p:spPr/>
@@ -1454,7 +1264,7 @@
 </file>
 
 <file path=ppt/notesSlides/notesSlide7.xml><?xml version="1.0" encoding="utf-8"?>
-<p:notes xmlns:a="http://schemas.openxmlformats.org/drawingml/2006/main" xmlns:p="http://schemas.openxmlformats.org/presentationml/2006/main" xmlns:r="http://schemas.openxmlformats.org/officeDocument/2006/relationships">
+<p:notes xmlns:a="http://schemas.openxmlformats.org/drawingml/2006/main" xmlns:r="http://schemas.openxmlformats.org/officeDocument/2006/relationships" xmlns:p="http://schemas.openxmlformats.org/presentationml/2006/main">
   <p:cSld>
     <p:spTree>
       <p:nvGrpSpPr>
@@ -1474,7 +1284,7 @@
         <p:nvSpPr>
           <p:cNvPr id="2" name="Slide Image Placeholder 1"/>
           <p:cNvSpPr>
-            <a:spLocks noGrp="1"/>
+            <a:spLocks noGrp="1" noRot="1" noChangeAspect="1"/>
           </p:cNvSpPr>
           <p:nvPr>
             <p:ph type="sldImg" idx="2"/>
@@ -1489,7 +1299,7 @@
             <a:spLocks noGrp="1"/>
           </p:cNvSpPr>
           <p:nvPr>
-            <p:ph type="body" idx="3" sz="quarter"/>
+            <p:ph type="body" sz="quarter" idx="3"/>
           </p:nvPr>
         </p:nvSpPr>
         <p:spPr/>
@@ -1510,7 +1320,7 @@
             <a:spLocks noGrp="1"/>
           </p:cNvSpPr>
           <p:nvPr>
-            <p:ph type="sldNum" idx="5" sz="quarter"/>
+            <p:ph type="sldNum" sz="quarter" idx="5"/>
           </p:nvPr>
         </p:nvSpPr>
         <p:spPr/>
@@ -1524,7 +1334,7 @@
 </file>
 
 <file path=ppt/notesSlides/notesSlide8.xml><?xml version="1.0" encoding="utf-8"?>
-<p:notes xmlns:a="http://schemas.openxmlformats.org/drawingml/2006/main" xmlns:p="http://schemas.openxmlformats.org/presentationml/2006/main" xmlns:r="http://schemas.openxmlformats.org/officeDocument/2006/relationships">
+<p:notes xmlns:a="http://schemas.openxmlformats.org/drawingml/2006/main" xmlns:r="http://schemas.openxmlformats.org/officeDocument/2006/relationships" xmlns:p="http://schemas.openxmlformats.org/presentationml/2006/main">
   <p:cSld>
     <p:spTree>
       <p:nvGrpSpPr>
@@ -1544,7 +1354,7 @@
         <p:nvSpPr>
           <p:cNvPr id="2" name="Slide Image Placeholder 1"/>
           <p:cNvSpPr>
-            <a:spLocks noGrp="1"/>
+            <a:spLocks noGrp="1" noRot="1" noChangeAspect="1"/>
           </p:cNvSpPr>
           <p:nvPr>
             <p:ph type="sldImg" idx="2"/>
@@ -1559,7 +1369,7 @@
             <a:spLocks noGrp="1"/>
           </p:cNvSpPr>
           <p:nvPr>
-            <p:ph type="body" idx="3" sz="quarter"/>
+            <p:ph type="body" sz="quarter" idx="3"/>
           </p:nvPr>
         </p:nvSpPr>
         <p:spPr/>
@@ -1580,7 +1390,7 @@
             <a:spLocks noGrp="1"/>
           </p:cNvSpPr>
           <p:nvPr>
-            <p:ph type="sldNum" idx="5" sz="quarter"/>
+            <p:ph type="sldNum" sz="quarter" idx="5"/>
           </p:nvPr>
         </p:nvSpPr>
         <p:spPr/>
@@ -1594,7 +1404,7 @@
 </file>
 
 <file path=ppt/notesSlides/notesSlide9.xml><?xml version="1.0" encoding="utf-8"?>
-<p:notes xmlns:a="http://schemas.openxmlformats.org/drawingml/2006/main" xmlns:p="http://schemas.openxmlformats.org/presentationml/2006/main" xmlns:r="http://schemas.openxmlformats.org/officeDocument/2006/relationships">
+<p:notes xmlns:a="http://schemas.openxmlformats.org/drawingml/2006/main" xmlns:r="http://schemas.openxmlformats.org/officeDocument/2006/relationships" xmlns:p="http://schemas.openxmlformats.org/presentationml/2006/main">
   <p:cSld>
     <p:spTree>
       <p:nvGrpSpPr>
@@ -1614,7 +1424,7 @@
         <p:nvSpPr>
           <p:cNvPr id="2" name="Slide Image Placeholder 1"/>
           <p:cNvSpPr>
-            <a:spLocks noGrp="1"/>
+            <a:spLocks noGrp="1" noRot="1" noChangeAspect="1"/>
           </p:cNvSpPr>
           <p:nvPr>
             <p:ph type="sldImg" idx="2"/>
@@ -1629,7 +1439,7 @@
             <a:spLocks noGrp="1"/>
           </p:cNvSpPr>
           <p:nvPr>
-            <p:ph type="body" idx="3" sz="quarter"/>
+            <p:ph type="body" sz="quarter" idx="3"/>
           </p:nvPr>
         </p:nvSpPr>
         <p:spPr/>
@@ -1650,7 +1460,7 @@
             <a:spLocks noGrp="1"/>
           </p:cNvSpPr>
           <p:nvPr>
-            <p:ph type="sldNum" idx="5" sz="quarter"/>
+            <p:ph type="sldNum" sz="quarter" idx="5"/>
           </p:nvPr>
         </p:nvSpPr>
         <p:spPr/>
@@ -1701,10 +1511,9 @@
           <a:lstStyle/>
           <a:p>
             <a:r>
-              <a:rPr lang="en-US" smtClean="0"/>
+              <a:rPr lang="en-US"/>
               <a:t>Click to edit Master title style</a:t>
             </a:r>
-            <a:endParaRPr lang="en-US"/>
           </a:p>
         </p:txBody>
       </p:sp>
@@ -1820,10 +1629,9 @@
           </a:lstStyle>
           <a:p>
             <a:r>
-              <a:rPr lang="en-US" smtClean="0"/>
+              <a:rPr lang="en-US"/>
               <a:t>Click to edit Master subtitle style</a:t>
             </a:r>
-            <a:endParaRPr lang="en-US"/>
           </a:p>
         </p:txBody>
       </p:sp>
@@ -1844,7 +1652,7 @@
           <a:p>
             <a:fld id="{5BCAD085-E8A6-8845-BD4E-CB4CCA059FC4}" type="datetimeFigureOut">
               <a:rPr lang="en-US" smtClean="0"/>
-              <a:t>1/27/13</a:t>
+              <a:t>9/29/26</a:t>
             </a:fld>
             <a:endParaRPr lang="en-US"/>
           </a:p>
@@ -1938,10 +1746,9 @@
           <a:lstStyle/>
           <a:p>
             <a:r>
-              <a:rPr lang="en-US" smtClean="0"/>
+              <a:rPr lang="en-US"/>
               <a:t>Click to edit Master title style</a:t>
             </a:r>
-            <a:endParaRPr lang="en-US"/>
           </a:p>
         </p:txBody>
       </p:sp>
@@ -1962,38 +1769,37 @@
           <a:p>
             <a:pPr lvl="0"/>
             <a:r>
-              <a:rPr lang="en-US" smtClean="0"/>
+              <a:rPr lang="en-US"/>
               <a:t>Click to edit Master text styles</a:t>
             </a:r>
           </a:p>
           <a:p>
             <a:pPr lvl="1"/>
             <a:r>
-              <a:rPr lang="en-US" smtClean="0"/>
+              <a:rPr lang="en-US"/>
               <a:t>Second level</a:t>
             </a:r>
           </a:p>
           <a:p>
             <a:pPr lvl="2"/>
             <a:r>
-              <a:rPr lang="en-US" smtClean="0"/>
+              <a:rPr lang="en-US"/>
               <a:t>Third level</a:t>
             </a:r>
           </a:p>
           <a:p>
             <a:pPr lvl="3"/>
             <a:r>
-              <a:rPr lang="en-US" smtClean="0"/>
+              <a:rPr lang="en-US"/>
               <a:t>Fourth level</a:t>
             </a:r>
           </a:p>
           <a:p>
             <a:pPr lvl="4"/>
             <a:r>
-              <a:rPr lang="en-US" smtClean="0"/>
+              <a:rPr lang="en-US"/>
               <a:t>Fifth level</a:t>
             </a:r>
-            <a:endParaRPr lang="en-US"/>
           </a:p>
         </p:txBody>
       </p:sp>
@@ -2014,7 +1820,7 @@
           <a:p>
             <a:fld id="{5BCAD085-E8A6-8845-BD4E-CB4CCA059FC4}" type="datetimeFigureOut">
               <a:rPr lang="en-US" smtClean="0"/>
-              <a:t>1/27/13</a:t>
+              <a:t>9/29/26</a:t>
             </a:fld>
             <a:endParaRPr lang="en-US"/>
           </a:p>
@@ -2113,10 +1919,9 @@
           <a:lstStyle/>
           <a:p>
             <a:r>
-              <a:rPr lang="en-US" smtClean="0"/>
+              <a:rPr lang="en-US"/>
               <a:t>Click to edit Master title style</a:t>
             </a:r>
-            <a:endParaRPr lang="en-US"/>
           </a:p>
         </p:txBody>
       </p:sp>
@@ -2142,38 +1947,37 @@
           <a:p>
             <a:pPr lvl="0"/>
             <a:r>
-              <a:rPr lang="en-US" smtClean="0"/>
+              <a:rPr lang="en-US"/>
               <a:t>Click to edit Master text styles</a:t>
             </a:r>
           </a:p>
           <a:p>
             <a:pPr lvl="1"/>
             <a:r>
-              <a:rPr lang="en-US" smtClean="0"/>
+              <a:rPr lang="en-US"/>
               <a:t>Second level</a:t>
             </a:r>
           </a:p>
           <a:p>
             <a:pPr lvl="2"/>
             <a:r>
-              <a:rPr lang="en-US" smtClean="0"/>
+              <a:rPr lang="en-US"/>
               <a:t>Third level</a:t>
             </a:r>
           </a:p>
           <a:p>
             <a:pPr lvl="3"/>
             <a:r>
-              <a:rPr lang="en-US" smtClean="0"/>
+              <a:rPr lang="en-US"/>
               <a:t>Fourth level</a:t>
             </a:r>
           </a:p>
           <a:p>
             <a:pPr lvl="4"/>
             <a:r>
-              <a:rPr lang="en-US" smtClean="0"/>
+              <a:rPr lang="en-US"/>
               <a:t>Fifth level</a:t>
             </a:r>
-            <a:endParaRPr lang="en-US"/>
           </a:p>
         </p:txBody>
       </p:sp>
@@ -2194,7 +1998,7 @@
           <a:p>
             <a:fld id="{5BCAD085-E8A6-8845-BD4E-CB4CCA059FC4}" type="datetimeFigureOut">
               <a:rPr lang="en-US" smtClean="0"/>
-              <a:t>1/27/13</a:t>
+              <a:t>9/29/26</a:t>
             </a:fld>
             <a:endParaRPr lang="en-US"/>
           </a:p>
@@ -2288,10 +2092,9 @@
           <a:lstStyle/>
           <a:p>
             <a:r>
-              <a:rPr lang="en-US" smtClean="0"/>
+              <a:rPr lang="en-US"/>
               <a:t>Click to edit Master title style</a:t>
             </a:r>
-            <a:endParaRPr lang="en-US"/>
           </a:p>
         </p:txBody>
       </p:sp>
@@ -2312,38 +2115,37 @@
           <a:p>
             <a:pPr lvl="0"/>
             <a:r>
-              <a:rPr lang="en-US" smtClean="0"/>
+              <a:rPr lang="en-US"/>
               <a:t>Click to edit Master text styles</a:t>
             </a:r>
           </a:p>
           <a:p>
             <a:pPr lvl="1"/>
             <a:r>
-              <a:rPr lang="en-US" smtClean="0"/>
+              <a:rPr lang="en-US"/>
               <a:t>Second level</a:t>
             </a:r>
           </a:p>
           <a:p>
             <a:pPr lvl="2"/>
             <a:r>
-              <a:rPr lang="en-US" smtClean="0"/>
+              <a:rPr lang="en-US"/>
               <a:t>Third level</a:t>
             </a:r>
           </a:p>
           <a:p>
             <a:pPr lvl="3"/>
             <a:r>
-              <a:rPr lang="en-US" smtClean="0"/>
+              <a:rPr lang="en-US"/>
               <a:t>Fourth level</a:t>
             </a:r>
           </a:p>
           <a:p>
             <a:pPr lvl="4"/>
             <a:r>
-              <a:rPr lang="en-US" smtClean="0"/>
+              <a:rPr lang="en-US"/>
               <a:t>Fifth level</a:t>
             </a:r>
-            <a:endParaRPr lang="en-US"/>
           </a:p>
         </p:txBody>
       </p:sp>
@@ -2364,7 +2166,7 @@
           <a:p>
             <a:fld id="{5BCAD085-E8A6-8845-BD4E-CB4CCA059FC4}" type="datetimeFigureOut">
               <a:rPr lang="en-US" smtClean="0"/>
-              <a:t>1/27/13</a:t>
+              <a:t>9/29/26</a:t>
             </a:fld>
             <a:endParaRPr lang="en-US"/>
           </a:p>
@@ -2467,10 +2269,9 @@
           </a:lstStyle>
           <a:p>
             <a:r>
-              <a:rPr lang="en-US" smtClean="0"/>
+              <a:rPr lang="en-US"/>
               <a:t>Click to edit Master title style</a:t>
             </a:r>
-            <a:endParaRPr lang="en-US"/>
           </a:p>
         </p:txBody>
       </p:sp>
@@ -2587,7 +2388,7 @@
           <a:p>
             <a:pPr lvl="0"/>
             <a:r>
-              <a:rPr lang="en-US" smtClean="0"/>
+              <a:rPr lang="en-US"/>
               <a:t>Click to edit Master text styles</a:t>
             </a:r>
           </a:p>
@@ -2610,7 +2411,7 @@
           <a:p>
             <a:fld id="{5BCAD085-E8A6-8845-BD4E-CB4CCA059FC4}" type="datetimeFigureOut">
               <a:rPr lang="en-US" smtClean="0"/>
-              <a:t>1/27/13</a:t>
+              <a:t>9/29/26</a:t>
             </a:fld>
             <a:endParaRPr lang="en-US"/>
           </a:p>
@@ -2704,10 +2505,9 @@
           <a:lstStyle/>
           <a:p>
             <a:r>
-              <a:rPr lang="en-US" smtClean="0"/>
+              <a:rPr lang="en-US"/>
               <a:t>Click to edit Master title style</a:t>
             </a:r>
-            <a:endParaRPr lang="en-US"/>
           </a:p>
         </p:txBody>
       </p:sp>
@@ -2761,38 +2561,37 @@
           <a:p>
             <a:pPr lvl="0"/>
             <a:r>
-              <a:rPr lang="en-US" smtClean="0"/>
+              <a:rPr lang="en-US"/>
               <a:t>Click to edit Master text styles</a:t>
             </a:r>
           </a:p>
           <a:p>
             <a:pPr lvl="1"/>
             <a:r>
-              <a:rPr lang="en-US" smtClean="0"/>
+              <a:rPr lang="en-US"/>
               <a:t>Second level</a:t>
             </a:r>
           </a:p>
           <a:p>
             <a:pPr lvl="2"/>
             <a:r>
-              <a:rPr lang="en-US" smtClean="0"/>
+              <a:rPr lang="en-US"/>
               <a:t>Third level</a:t>
             </a:r>
           </a:p>
           <a:p>
             <a:pPr lvl="3"/>
             <a:r>
-              <a:rPr lang="en-US" smtClean="0"/>
+              <a:rPr lang="en-US"/>
               <a:t>Fourth level</a:t>
             </a:r>
           </a:p>
           <a:p>
             <a:pPr lvl="4"/>
             <a:r>
-              <a:rPr lang="en-US" smtClean="0"/>
+              <a:rPr lang="en-US"/>
               <a:t>Fifth level</a:t>
             </a:r>
-            <a:endParaRPr lang="en-US"/>
           </a:p>
         </p:txBody>
       </p:sp>
@@ -2846,38 +2645,37 @@
           <a:p>
             <a:pPr lvl="0"/>
             <a:r>
-              <a:rPr lang="en-US" smtClean="0"/>
+              <a:rPr lang="en-US"/>
               <a:t>Click to edit Master text styles</a:t>
             </a:r>
           </a:p>
           <a:p>
             <a:pPr lvl="1"/>
             <a:r>
-              <a:rPr lang="en-US" smtClean="0"/>
+              <a:rPr lang="en-US"/>
               <a:t>Second level</a:t>
             </a:r>
           </a:p>
           <a:p>
             <a:pPr lvl="2"/>
             <a:r>
-              <a:rPr lang="en-US" smtClean="0"/>
+              <a:rPr lang="en-US"/>
               <a:t>Third level</a:t>
             </a:r>
           </a:p>
           <a:p>
             <a:pPr lvl="3"/>
             <a:r>
-              <a:rPr lang="en-US" smtClean="0"/>
+              <a:rPr lang="en-US"/>
               <a:t>Fourth level</a:t>
             </a:r>
           </a:p>
           <a:p>
             <a:pPr lvl="4"/>
             <a:r>
-              <a:rPr lang="en-US" smtClean="0"/>
+              <a:rPr lang="en-US"/>
               <a:t>Fifth level</a:t>
             </a:r>
-            <a:endParaRPr lang="en-US"/>
           </a:p>
         </p:txBody>
       </p:sp>
@@ -2898,7 +2696,7 @@
           <a:p>
             <a:fld id="{5BCAD085-E8A6-8845-BD4E-CB4CCA059FC4}" type="datetimeFigureOut">
               <a:rPr lang="en-US" smtClean="0"/>
-              <a:t>1/27/13</a:t>
+              <a:t>9/29/26</a:t>
             </a:fld>
             <a:endParaRPr lang="en-US"/>
           </a:p>
@@ -2996,10 +2794,9 @@
           </a:lstStyle>
           <a:p>
             <a:r>
-              <a:rPr lang="en-US" smtClean="0"/>
+              <a:rPr lang="en-US"/>
               <a:t>Click to edit Master title style</a:t>
             </a:r>
-            <a:endParaRPr lang="en-US"/>
           </a:p>
         </p:txBody>
       </p:sp>
@@ -3062,7 +2859,7 @@
           <a:p>
             <a:pPr lvl="0"/>
             <a:r>
-              <a:rPr lang="en-US" smtClean="0"/>
+              <a:rPr lang="en-US"/>
               <a:t>Click to edit Master text styles</a:t>
             </a:r>
           </a:p>
@@ -3118,38 +2915,37 @@
           <a:p>
             <a:pPr lvl="0"/>
             <a:r>
-              <a:rPr lang="en-US" smtClean="0"/>
+              <a:rPr lang="en-US"/>
               <a:t>Click to edit Master text styles</a:t>
             </a:r>
           </a:p>
           <a:p>
             <a:pPr lvl="1"/>
             <a:r>
-              <a:rPr lang="en-US" smtClean="0"/>
+              <a:rPr lang="en-US"/>
               <a:t>Second level</a:t>
             </a:r>
           </a:p>
           <a:p>
             <a:pPr lvl="2"/>
             <a:r>
-              <a:rPr lang="en-US" smtClean="0"/>
+              <a:rPr lang="en-US"/>
               <a:t>Third level</a:t>
             </a:r>
           </a:p>
           <a:p>
             <a:pPr lvl="3"/>
             <a:r>
-              <a:rPr lang="en-US" smtClean="0"/>
+              <a:rPr lang="en-US"/>
               <a:t>Fourth level</a:t>
             </a:r>
           </a:p>
           <a:p>
             <a:pPr lvl="4"/>
             <a:r>
-              <a:rPr lang="en-US" smtClean="0"/>
+              <a:rPr lang="en-US"/>
               <a:t>Fifth level</a:t>
             </a:r>
-            <a:endParaRPr lang="en-US"/>
           </a:p>
         </p:txBody>
       </p:sp>
@@ -3212,7 +3008,7 @@
           <a:p>
             <a:pPr lvl="0"/>
             <a:r>
-              <a:rPr lang="en-US" smtClean="0"/>
+              <a:rPr lang="en-US"/>
               <a:t>Click to edit Master text styles</a:t>
             </a:r>
           </a:p>
@@ -3268,38 +3064,37 @@
           <a:p>
             <a:pPr lvl="0"/>
             <a:r>
-              <a:rPr lang="en-US" smtClean="0"/>
+              <a:rPr lang="en-US"/>
               <a:t>Click to edit Master text styles</a:t>
             </a:r>
           </a:p>
           <a:p>
             <a:pPr lvl="1"/>
             <a:r>
-              <a:rPr lang="en-US" smtClean="0"/>
+              <a:rPr lang="en-US"/>
               <a:t>Second level</a:t>
             </a:r>
           </a:p>
           <a:p>
             <a:pPr lvl="2"/>
             <a:r>
-              <a:rPr lang="en-US" smtClean="0"/>
+              <a:rPr lang="en-US"/>
               <a:t>Third level</a:t>
             </a:r>
           </a:p>
           <a:p>
             <a:pPr lvl="3"/>
             <a:r>
-              <a:rPr lang="en-US" smtClean="0"/>
+              <a:rPr lang="en-US"/>
               <a:t>Fourth level</a:t>
             </a:r>
           </a:p>
           <a:p>
             <a:pPr lvl="4"/>
             <a:r>
-              <a:rPr lang="en-US" smtClean="0"/>
+              <a:rPr lang="en-US"/>
               <a:t>Fifth level</a:t>
             </a:r>
-            <a:endParaRPr lang="en-US"/>
           </a:p>
         </p:txBody>
       </p:sp>
@@ -3320,7 +3115,7 @@
           <a:p>
             <a:fld id="{5BCAD085-E8A6-8845-BD4E-CB4CCA059FC4}" type="datetimeFigureOut">
               <a:rPr lang="en-US" smtClean="0"/>
-              <a:t>1/27/13</a:t>
+              <a:t>9/29/26</a:t>
             </a:fld>
             <a:endParaRPr lang="en-US"/>
           </a:p>
@@ -3414,10 +3209,9 @@
           <a:lstStyle/>
           <a:p>
             <a:r>
-              <a:rPr lang="en-US" smtClean="0"/>
+              <a:rPr lang="en-US"/>
               <a:t>Click to edit Master title style</a:t>
             </a:r>
-            <a:endParaRPr lang="en-US"/>
           </a:p>
         </p:txBody>
       </p:sp>
@@ -3438,7 +3232,7 @@
           <a:p>
             <a:fld id="{5BCAD085-E8A6-8845-BD4E-CB4CCA059FC4}" type="datetimeFigureOut">
               <a:rPr lang="en-US" smtClean="0"/>
-              <a:t>1/27/13</a:t>
+              <a:t>9/29/26</a:t>
             </a:fld>
             <a:endParaRPr lang="en-US"/>
           </a:p>
@@ -3533,7 +3327,7 @@
           <a:p>
             <a:fld id="{5BCAD085-E8A6-8845-BD4E-CB4CCA059FC4}" type="datetimeFigureOut">
               <a:rPr lang="en-US" smtClean="0"/>
-              <a:t>1/27/13</a:t>
+              <a:t>9/29/26</a:t>
             </a:fld>
             <a:endParaRPr lang="en-US"/>
           </a:p>
@@ -3636,10 +3430,9 @@
           </a:lstStyle>
           <a:p>
             <a:r>
-              <a:rPr lang="en-US" smtClean="0"/>
+              <a:rPr lang="en-US"/>
               <a:t>Click to edit Master title style</a:t>
             </a:r>
-            <a:endParaRPr lang="en-US"/>
           </a:p>
         </p:txBody>
       </p:sp>
@@ -3693,38 +3486,37 @@
           <a:p>
             <a:pPr lvl="0"/>
             <a:r>
-              <a:rPr lang="en-US" smtClean="0"/>
+              <a:rPr lang="en-US"/>
               <a:t>Click to edit Master text styles</a:t>
             </a:r>
           </a:p>
           <a:p>
             <a:pPr lvl="1"/>
             <a:r>
-              <a:rPr lang="en-US" smtClean="0"/>
+              <a:rPr lang="en-US"/>
               <a:t>Second level</a:t>
             </a:r>
           </a:p>
           <a:p>
             <a:pPr lvl="2"/>
             <a:r>
-              <a:rPr lang="en-US" smtClean="0"/>
+              <a:rPr lang="en-US"/>
               <a:t>Third level</a:t>
             </a:r>
           </a:p>
           <a:p>
             <a:pPr lvl="3"/>
             <a:r>
-              <a:rPr lang="en-US" smtClean="0"/>
+              <a:rPr lang="en-US"/>
               <a:t>Fourth level</a:t>
             </a:r>
           </a:p>
           <a:p>
             <a:pPr lvl="4"/>
             <a:r>
-              <a:rPr lang="en-US" smtClean="0"/>
+              <a:rPr lang="en-US"/>
               <a:t>Fifth level</a:t>
             </a:r>
-            <a:endParaRPr lang="en-US"/>
           </a:p>
         </p:txBody>
       </p:sp>
@@ -3787,7 +3579,7 @@
           <a:p>
             <a:pPr lvl="0"/>
             <a:r>
-              <a:rPr lang="en-US" smtClean="0"/>
+              <a:rPr lang="en-US"/>
               <a:t>Click to edit Master text styles</a:t>
             </a:r>
           </a:p>
@@ -3810,7 +3602,7 @@
           <a:p>
             <a:fld id="{5BCAD085-E8A6-8845-BD4E-CB4CCA059FC4}" type="datetimeFigureOut">
               <a:rPr lang="en-US" smtClean="0"/>
-              <a:t>1/27/13</a:t>
+              <a:t>9/29/26</a:t>
             </a:fld>
             <a:endParaRPr lang="en-US"/>
           </a:p>
@@ -3913,10 +3705,9 @@
           </a:lstStyle>
           <a:p>
             <a:r>
-              <a:rPr lang="en-US" smtClean="0"/>
+              <a:rPr lang="en-US"/>
               <a:t>Click to edit Master title style</a:t>
             </a:r>
-            <a:endParaRPr lang="en-US"/>
           </a:p>
         </p:txBody>
       </p:sp>
@@ -4040,7 +3831,7 @@
           <a:p>
             <a:pPr lvl="0"/>
             <a:r>
-              <a:rPr lang="en-US" smtClean="0"/>
+              <a:rPr lang="en-US"/>
               <a:t>Click to edit Master text styles</a:t>
             </a:r>
           </a:p>
@@ -4063,7 +3854,7 @@
           <a:p>
             <a:fld id="{5BCAD085-E8A6-8845-BD4E-CB4CCA059FC4}" type="datetimeFigureOut">
               <a:rPr lang="en-US" smtClean="0"/>
-              <a:t>1/27/13</a:t>
+              <a:t>9/29/26</a:t>
             </a:fld>
             <a:endParaRPr lang="en-US"/>
           </a:p>
@@ -4172,10 +3963,9 @@
           <a:lstStyle/>
           <a:p>
             <a:r>
-              <a:rPr lang="en-US" smtClean="0"/>
+              <a:rPr lang="en-US"/>
               <a:t>Click to edit Master title style</a:t>
             </a:r>
-            <a:endParaRPr lang="en-US"/>
           </a:p>
         </p:txBody>
       </p:sp>
@@ -4206,38 +3996,37 @@
           <a:p>
             <a:pPr lvl="0"/>
             <a:r>
-              <a:rPr lang="en-US" smtClean="0"/>
+              <a:rPr lang="en-US"/>
               <a:t>Click to edit Master text styles</a:t>
             </a:r>
           </a:p>
           <a:p>
             <a:pPr lvl="1"/>
             <a:r>
-              <a:rPr lang="en-US" smtClean="0"/>
+              <a:rPr lang="en-US"/>
               <a:t>Second level</a:t>
             </a:r>
           </a:p>
           <a:p>
             <a:pPr lvl="2"/>
             <a:r>
-              <a:rPr lang="en-US" smtClean="0"/>
+              <a:rPr lang="en-US"/>
               <a:t>Third level</a:t>
             </a:r>
           </a:p>
           <a:p>
             <a:pPr lvl="3"/>
             <a:r>
-              <a:rPr lang="en-US" smtClean="0"/>
+              <a:rPr lang="en-US"/>
               <a:t>Fourth level</a:t>
             </a:r>
           </a:p>
           <a:p>
             <a:pPr lvl="4"/>
             <a:r>
-              <a:rPr lang="en-US" smtClean="0"/>
+              <a:rPr lang="en-US"/>
               <a:t>Fifth level</a:t>
             </a:r>
-            <a:endParaRPr lang="en-US"/>
           </a:p>
         </p:txBody>
       </p:sp>
@@ -4276,7 +4065,7 @@
           <a:p>
             <a:fld id="{5BCAD085-E8A6-8845-BD4E-CB4CCA059FC4}" type="datetimeFigureOut">
               <a:rPr lang="en-US" smtClean="0"/>
-              <a:t>1/27/13</a:t>
+              <a:t>9/29/26</a:t>
             </a:fld>
             <a:endParaRPr lang="en-US"/>
           </a:p>
@@ -4635,7 +4424,7 @@
 </file>
 
 <file path=ppt/slides/slide1.xml><?xml version="1.0" encoding="utf-8"?>
-<p:sld xmlns:a="http://schemas.openxmlformats.org/drawingml/2006/main" xmlns:p="http://schemas.openxmlformats.org/presentationml/2006/main" xmlns:r="http://schemas.openxmlformats.org/officeDocument/2006/relationships">
+<p:sld xmlns:a="http://schemas.openxmlformats.org/drawingml/2006/main" xmlns:r="http://schemas.openxmlformats.org/officeDocument/2006/relationships" xmlns:p="http://schemas.openxmlformats.org/presentationml/2006/main">
   <p:cSld>
     <p:bg>
       <p:bgPr>
@@ -4651,7 +4440,14 @@
         <p:cNvGrpSpPr/>
         <p:nvPr/>
       </p:nvGrpSpPr>
-      <p:grpSpPr/>
+      <p:grpSpPr>
+        <a:xfrm>
+          <a:off x="0" y="0"/>
+          <a:ext cx="0" cy="0"/>
+          <a:chOff x="0" y="0"/>
+          <a:chExt cx="0" cy="0"/>
+        </a:xfrm>
+      </p:grpSpPr>
       <p:sp>
         <p:nvSpPr>
           <p:cNvPr id="2" name="TextBox 1"/>
@@ -4819,7 +4615,7 @@
 </file>
 
 <file path=ppt/slides/slide10.xml><?xml version="1.0" encoding="utf-8"?>
-<p:sld xmlns:a="http://schemas.openxmlformats.org/drawingml/2006/main" xmlns:p="http://schemas.openxmlformats.org/presentationml/2006/main" xmlns:r="http://schemas.openxmlformats.org/officeDocument/2006/relationships">
+<p:sld xmlns:a="http://schemas.openxmlformats.org/drawingml/2006/main" xmlns:r="http://schemas.openxmlformats.org/officeDocument/2006/relationships" xmlns:p="http://schemas.openxmlformats.org/presentationml/2006/main">
   <p:cSld>
     <p:bg>
       <p:bgPr>
@@ -4835,7 +4631,14 @@
         <p:cNvGrpSpPr/>
         <p:nvPr/>
       </p:nvGrpSpPr>
-      <p:grpSpPr/>
+      <p:grpSpPr>
+        <a:xfrm>
+          <a:off x="0" y="0"/>
+          <a:ext cx="0" cy="0"/>
+          <a:chOff x="0" y="0"/>
+          <a:chExt cx="0" cy="0"/>
+        </a:xfrm>
+      </p:grpSpPr>
       <p:sp>
         <p:nvSpPr>
           <p:cNvPr id="2" name="Rectangle 1"/>
@@ -4876,6 +4679,7 @@
           <a:lstStyle/>
           <a:p>
             <a:pPr algn="ctr"/>
+            <a:endParaRPr/>
           </a:p>
         </p:txBody>
       </p:sp>
@@ -5077,7 +4881,7 @@
 </file>
 
 <file path=ppt/slides/slide11.xml><?xml version="1.0" encoding="utf-8"?>
-<p:sld xmlns:a="http://schemas.openxmlformats.org/drawingml/2006/main" xmlns:p="http://schemas.openxmlformats.org/presentationml/2006/main" xmlns:r="http://schemas.openxmlformats.org/officeDocument/2006/relationships">
+<p:sld xmlns:a="http://schemas.openxmlformats.org/drawingml/2006/main" xmlns:r="http://schemas.openxmlformats.org/officeDocument/2006/relationships" xmlns:p="http://schemas.openxmlformats.org/presentationml/2006/main">
   <p:cSld>
     <p:bg>
       <p:bgPr>
@@ -5093,7 +4897,14 @@
         <p:cNvGrpSpPr/>
         <p:nvPr/>
       </p:nvGrpSpPr>
-      <p:grpSpPr/>
+      <p:grpSpPr>
+        <a:xfrm>
+          <a:off x="0" y="0"/>
+          <a:ext cx="0" cy="0"/>
+          <a:chOff x="0" y="0"/>
+          <a:chExt cx="0" cy="0"/>
+        </a:xfrm>
+      </p:grpSpPr>
       <p:sp>
         <p:nvSpPr>
           <p:cNvPr id="2" name="Rectangle 1"/>
@@ -5134,6 +4945,7 @@
           <a:lstStyle/>
           <a:p>
             <a:pPr algn="ctr"/>
+            <a:endParaRPr/>
           </a:p>
         </p:txBody>
       </p:sp>
@@ -5272,7 +5084,7 @@
           <p:nvPr/>
         </p:nvPicPr>
         <p:blipFill>
-          <a:blip r:embed="rId2"/>
+          <a:blip r:embed="rId3"/>
           <a:stretch>
             <a:fillRect/>
           </a:stretch>
@@ -5296,7 +5108,7 @@
           <p:nvPr/>
         </p:nvPicPr>
         <p:blipFill>
-          <a:blip r:embed="rId3"/>
+          <a:blip r:embed="rId4"/>
           <a:stretch>
             <a:fillRect/>
           </a:stretch>
@@ -5354,7 +5166,7 @@
           <p:nvPr/>
         </p:nvPicPr>
         <p:blipFill>
-          <a:blip r:embed="rId4"/>
+          <a:blip r:embed="rId5"/>
           <a:stretch>
             <a:fillRect/>
           </a:stretch>
@@ -5378,7 +5190,7 @@
           <p:nvPr/>
         </p:nvPicPr>
         <p:blipFill>
-          <a:blip r:embed="rId5"/>
+          <a:blip r:embed="rId6"/>
           <a:stretch>
             <a:fillRect/>
           </a:stretch>
@@ -5469,7 +5281,7 @@
 </file>
 
 <file path=ppt/slides/slide12.xml><?xml version="1.0" encoding="utf-8"?>
-<p:sld xmlns:a="http://schemas.openxmlformats.org/drawingml/2006/main" xmlns:p="http://schemas.openxmlformats.org/presentationml/2006/main" xmlns:r="http://schemas.openxmlformats.org/officeDocument/2006/relationships">
+<p:sld xmlns:a="http://schemas.openxmlformats.org/drawingml/2006/main" xmlns:r="http://schemas.openxmlformats.org/officeDocument/2006/relationships" xmlns:p="http://schemas.openxmlformats.org/presentationml/2006/main">
   <p:cSld>
     <p:bg>
       <p:bgPr>
@@ -5485,7 +5297,14 @@
         <p:cNvGrpSpPr/>
         <p:nvPr/>
       </p:nvGrpSpPr>
-      <p:grpSpPr/>
+      <p:grpSpPr>
+        <a:xfrm>
+          <a:off x="0" y="0"/>
+          <a:ext cx="0" cy="0"/>
+          <a:chOff x="0" y="0"/>
+          <a:chExt cx="0" cy="0"/>
+        </a:xfrm>
+      </p:grpSpPr>
       <p:sp>
         <p:nvSpPr>
           <p:cNvPr id="2" name="Rectangle 1"/>
@@ -5526,6 +5345,7 @@
           <a:lstStyle/>
           <a:p>
             <a:pPr algn="ctr"/>
+            <a:endParaRPr/>
           </a:p>
         </p:txBody>
       </p:sp>
@@ -5772,7 +5592,7 @@
 </file>
 
 <file path=ppt/slides/slide13.xml><?xml version="1.0" encoding="utf-8"?>
-<p:sld xmlns:a="http://schemas.openxmlformats.org/drawingml/2006/main" xmlns:p="http://schemas.openxmlformats.org/presentationml/2006/main" xmlns:r="http://schemas.openxmlformats.org/officeDocument/2006/relationships">
+<p:sld xmlns:a="http://schemas.openxmlformats.org/drawingml/2006/main" xmlns:r="http://schemas.openxmlformats.org/officeDocument/2006/relationships" xmlns:p="http://schemas.openxmlformats.org/presentationml/2006/main">
   <p:cSld>
     <p:bg>
       <p:bgPr>
@@ -5788,7 +5608,14 @@
         <p:cNvGrpSpPr/>
         <p:nvPr/>
       </p:nvGrpSpPr>
-      <p:grpSpPr/>
+      <p:grpSpPr>
+        <a:xfrm>
+          <a:off x="0" y="0"/>
+          <a:ext cx="0" cy="0"/>
+          <a:chOff x="0" y="0"/>
+          <a:chExt cx="0" cy="0"/>
+        </a:xfrm>
+      </p:grpSpPr>
       <p:sp>
         <p:nvSpPr>
           <p:cNvPr id="2" name="Rectangle 1"/>
@@ -5829,6 +5656,7 @@
           <a:lstStyle/>
           <a:p>
             <a:pPr algn="ctr"/>
+            <a:endParaRPr/>
           </a:p>
         </p:txBody>
       </p:sp>
@@ -5950,6 +5778,7 @@
           <a:lstStyle/>
           <a:p>
             <a:pPr algn="ctr"/>
+            <a:endParaRPr/>
           </a:p>
         </p:txBody>
       </p:sp>
@@ -6072,6 +5901,7 @@
           <a:lstStyle/>
           <a:p>
             <a:pPr algn="ctr"/>
+            <a:endParaRPr/>
           </a:p>
         </p:txBody>
       </p:sp>
@@ -6194,6 +6024,7 @@
           <a:lstStyle/>
           <a:p>
             <a:pPr algn="ctr"/>
+            <a:endParaRPr/>
           </a:p>
         </p:txBody>
       </p:sp>
@@ -6316,6 +6147,7 @@
           <a:lstStyle/>
           <a:p>
             <a:pPr algn="ctr"/>
+            <a:endParaRPr/>
           </a:p>
         </p:txBody>
       </p:sp>
@@ -6438,6 +6270,7 @@
           <a:lstStyle/>
           <a:p>
             <a:pPr algn="ctr"/>
+            <a:endParaRPr/>
           </a:p>
         </p:txBody>
       </p:sp>
@@ -6560,6 +6393,7 @@
           <a:lstStyle/>
           <a:p>
             <a:pPr algn="ctr"/>
+            <a:endParaRPr/>
           </a:p>
         </p:txBody>
       </p:sp>
@@ -6682,6 +6516,7 @@
           <a:lstStyle/>
           <a:p>
             <a:pPr algn="ctr"/>
+            <a:endParaRPr/>
           </a:p>
         </p:txBody>
       </p:sp>
@@ -6804,6 +6639,7 @@
           <a:lstStyle/>
           <a:p>
             <a:pPr algn="ctr"/>
+            <a:endParaRPr/>
           </a:p>
         </p:txBody>
       </p:sp>
@@ -6961,7 +6797,7 @@
 </file>
 
 <file path=ppt/slides/slide14.xml><?xml version="1.0" encoding="utf-8"?>
-<p:sld xmlns:a="http://schemas.openxmlformats.org/drawingml/2006/main" xmlns:p="http://schemas.openxmlformats.org/presentationml/2006/main" xmlns:r="http://schemas.openxmlformats.org/officeDocument/2006/relationships">
+<p:sld xmlns:a="http://schemas.openxmlformats.org/drawingml/2006/main" xmlns:r="http://schemas.openxmlformats.org/officeDocument/2006/relationships" xmlns:p="http://schemas.openxmlformats.org/presentationml/2006/main">
   <p:cSld>
     <p:bg>
       <p:bgPr>
@@ -6977,7 +6813,14 @@
         <p:cNvGrpSpPr/>
         <p:nvPr/>
       </p:nvGrpSpPr>
-      <p:grpSpPr/>
+      <p:grpSpPr>
+        <a:xfrm>
+          <a:off x="0" y="0"/>
+          <a:ext cx="0" cy="0"/>
+          <a:chOff x="0" y="0"/>
+          <a:chExt cx="0" cy="0"/>
+        </a:xfrm>
+      </p:grpSpPr>
       <p:sp>
         <p:nvSpPr>
           <p:cNvPr id="2" name="Rectangle 1"/>
@@ -7018,6 +6861,7 @@
           <a:lstStyle/>
           <a:p>
             <a:pPr algn="ctr"/>
+            <a:endParaRPr/>
           </a:p>
         </p:txBody>
       </p:sp>
@@ -7104,7 +6948,7 @@
           </a:fontRef>
         </p:style>
         <p:txBody>
-          <a:bodyPr rtlCol="0" anchor="ctr" wrap="square" lIns="127000" rIns="127000" tIns="127000"/>
+          <a:bodyPr wrap="square" lIns="127000" tIns="127000" rIns="127000" rtlCol="0" anchor="ctr"/>
           <a:lstStyle/>
           <a:p>
             <a:pPr algn="ctr"/>
@@ -7195,7 +7039,7 @@
           </a:fontRef>
         </p:style>
         <p:txBody>
-          <a:bodyPr rtlCol="0" anchor="ctr" wrap="none" lIns="50800" rIns="50800" tIns="12700" bIns="12700"/>
+          <a:bodyPr wrap="none" lIns="50800" tIns="12700" rIns="50800" bIns="12700" rtlCol="0" anchor="ctr"/>
           <a:lstStyle/>
           <a:p>
             <a:pPr algn="ctr"/>
@@ -7250,7 +7094,7 @@
           </a:fontRef>
         </p:style>
         <p:txBody>
-          <a:bodyPr rtlCol="0" anchor="ctr" wrap="square" lIns="127000" rIns="127000" tIns="127000"/>
+          <a:bodyPr wrap="square" lIns="127000" tIns="127000" rIns="127000" rtlCol="0" anchor="ctr"/>
           <a:lstStyle/>
           <a:p>
             <a:pPr algn="ctr"/>
@@ -7341,7 +7185,7 @@
           </a:fontRef>
         </p:style>
         <p:txBody>
-          <a:bodyPr rtlCol="0" anchor="ctr" wrap="none" lIns="50800" rIns="50800" tIns="12700" bIns="12700"/>
+          <a:bodyPr wrap="none" lIns="50800" tIns="12700" rIns="50800" bIns="12700" rtlCol="0" anchor="ctr"/>
           <a:lstStyle/>
           <a:p>
             <a:pPr algn="ctr"/>
@@ -7396,7 +7240,7 @@
           </a:fontRef>
         </p:style>
         <p:txBody>
-          <a:bodyPr rtlCol="0" anchor="ctr" wrap="square" lIns="127000" rIns="127000" tIns="127000"/>
+          <a:bodyPr wrap="square" lIns="127000" tIns="127000" rIns="127000" rtlCol="0" anchor="ctr"/>
           <a:lstStyle/>
           <a:p>
             <a:pPr algn="ctr"/>
@@ -7487,7 +7331,7 @@
           </a:fontRef>
         </p:style>
         <p:txBody>
-          <a:bodyPr rtlCol="0" anchor="ctr" wrap="none" lIns="50800" rIns="50800" tIns="12700" bIns="12700"/>
+          <a:bodyPr wrap="none" lIns="50800" tIns="12700" rIns="50800" bIns="12700" rtlCol="0" anchor="ctr"/>
           <a:lstStyle/>
           <a:p>
             <a:pPr algn="ctr"/>
@@ -7542,7 +7386,7 @@
           </a:fontRef>
         </p:style>
         <p:txBody>
-          <a:bodyPr rtlCol="0" anchor="ctr" wrap="square" lIns="127000" rIns="127000" tIns="127000"/>
+          <a:bodyPr wrap="square" lIns="127000" tIns="127000" rIns="127000" rtlCol="0" anchor="ctr"/>
           <a:lstStyle/>
           <a:p>
             <a:pPr algn="ctr"/>
@@ -7633,7 +7477,7 @@
           </a:fontRef>
         </p:style>
         <p:txBody>
-          <a:bodyPr rtlCol="0" anchor="ctr" wrap="none" lIns="50800" rIns="50800" tIns="12700" bIns="12700"/>
+          <a:bodyPr wrap="none" lIns="50800" tIns="12700" rIns="50800" bIns="12700" rtlCol="0" anchor="ctr"/>
           <a:lstStyle/>
           <a:p>
             <a:pPr algn="ctr"/>
@@ -7688,7 +7532,7 @@
           </a:fontRef>
         </p:style>
         <p:txBody>
-          <a:bodyPr rtlCol="0" anchor="ctr" wrap="square" lIns="127000" rIns="127000" tIns="127000"/>
+          <a:bodyPr wrap="square" lIns="127000" tIns="127000" rIns="127000" rtlCol="0" anchor="ctr"/>
           <a:lstStyle/>
           <a:p>
             <a:pPr algn="ctr"/>
@@ -7779,7 +7623,7 @@
           </a:fontRef>
         </p:style>
         <p:txBody>
-          <a:bodyPr rtlCol="0" anchor="ctr" wrap="none" lIns="50800" rIns="50800" tIns="12700" bIns="12700"/>
+          <a:bodyPr wrap="none" lIns="50800" tIns="12700" rIns="50800" bIns="12700" rtlCol="0" anchor="ctr"/>
           <a:lstStyle/>
           <a:p>
             <a:pPr algn="ctr"/>
@@ -7802,7 +7646,7 @@
         </p:nvSpPr>
         <p:spPr>
           <a:xfrm>
-            <a:off x="6035040" y="3657600"/>
+            <a:off x="8158276" y="3657600"/>
             <a:ext cx="3576218" cy="2103120"/>
           </a:xfrm>
           <a:prstGeom prst="roundRect">
@@ -7832,7 +7676,7 @@
           </a:fontRef>
         </p:style>
         <p:txBody>
-          <a:bodyPr rtlCol="0" anchor="ctr" wrap="square" lIns="127000" rIns="127000" tIns="127000"/>
+          <a:bodyPr wrap="square" lIns="127000" tIns="127000" rIns="127000" rtlCol="0" anchor="ctr"/>
           <a:lstStyle/>
           <a:p>
             <a:pPr algn="ctr"/>
@@ -7904,7 +7748,7 @@
 </file>
 
 <file path=ppt/slides/slide15.xml><?xml version="1.0" encoding="utf-8"?>
-<p:sld xmlns:a="http://schemas.openxmlformats.org/drawingml/2006/main" xmlns:p="http://schemas.openxmlformats.org/presentationml/2006/main" xmlns:r="http://schemas.openxmlformats.org/officeDocument/2006/relationships">
+<p:sld xmlns:a="http://schemas.openxmlformats.org/drawingml/2006/main" xmlns:r="http://schemas.openxmlformats.org/officeDocument/2006/relationships" xmlns:p="http://schemas.openxmlformats.org/presentationml/2006/main">
   <p:cSld>
     <p:bg>
       <p:bgPr>
@@ -7920,7 +7764,14 @@
         <p:cNvGrpSpPr/>
         <p:nvPr/>
       </p:nvGrpSpPr>
-      <p:grpSpPr/>
+      <p:grpSpPr>
+        <a:xfrm>
+          <a:off x="0" y="0"/>
+          <a:ext cx="0" cy="0"/>
+          <a:chOff x="0" y="0"/>
+          <a:chExt cx="0" cy="0"/>
+        </a:xfrm>
+      </p:grpSpPr>
       <p:sp>
         <p:nvSpPr>
           <p:cNvPr id="2" name="Rectangle 1"/>
@@ -7961,6 +7812,7 @@
           <a:lstStyle/>
           <a:p>
             <a:pPr algn="ctr"/>
+            <a:endParaRPr/>
           </a:p>
         </p:txBody>
       </p:sp>
@@ -8132,7 +7984,7 @@
 </file>
 
 <file path=ppt/slides/slide16.xml><?xml version="1.0" encoding="utf-8"?>
-<p:sld xmlns:a="http://schemas.openxmlformats.org/drawingml/2006/main" xmlns:p="http://schemas.openxmlformats.org/presentationml/2006/main" xmlns:r="http://schemas.openxmlformats.org/officeDocument/2006/relationships">
+<p:sld xmlns:a="http://schemas.openxmlformats.org/drawingml/2006/main" xmlns:r="http://schemas.openxmlformats.org/officeDocument/2006/relationships" xmlns:p="http://schemas.openxmlformats.org/presentationml/2006/main">
   <p:cSld>
     <p:bg>
       <p:bgPr>
@@ -8148,7 +8000,14 @@
         <p:cNvGrpSpPr/>
         <p:nvPr/>
       </p:nvGrpSpPr>
-      <p:grpSpPr/>
+      <p:grpSpPr>
+        <a:xfrm>
+          <a:off x="0" y="0"/>
+          <a:ext cx="0" cy="0"/>
+          <a:chOff x="0" y="0"/>
+          <a:chExt cx="0" cy="0"/>
+        </a:xfrm>
+      </p:grpSpPr>
       <p:sp>
         <p:nvSpPr>
           <p:cNvPr id="2" name="Rectangle 1"/>
@@ -8189,6 +8048,7 @@
           <a:lstStyle/>
           <a:p>
             <a:pPr algn="ctr"/>
+            <a:endParaRPr/>
           </a:p>
         </p:txBody>
       </p:sp>
@@ -8390,7 +8250,7 @@
 </file>
 
 <file path=ppt/slides/slide17.xml><?xml version="1.0" encoding="utf-8"?>
-<p:sld xmlns:a="http://schemas.openxmlformats.org/drawingml/2006/main" xmlns:p="http://schemas.openxmlformats.org/presentationml/2006/main" xmlns:r="http://schemas.openxmlformats.org/officeDocument/2006/relationships">
+<p:sld xmlns:a="http://schemas.openxmlformats.org/drawingml/2006/main" xmlns:r="http://schemas.openxmlformats.org/officeDocument/2006/relationships" xmlns:p="http://schemas.openxmlformats.org/presentationml/2006/main">
   <p:cSld>
     <p:bg>
       <p:bgPr>
@@ -8406,7 +8266,14 @@
         <p:cNvGrpSpPr/>
         <p:nvPr/>
       </p:nvGrpSpPr>
-      <p:grpSpPr/>
+      <p:grpSpPr>
+        <a:xfrm>
+          <a:off x="0" y="0"/>
+          <a:ext cx="0" cy="0"/>
+          <a:chOff x="0" y="0"/>
+          <a:chExt cx="0" cy="0"/>
+        </a:xfrm>
+      </p:grpSpPr>
       <p:sp>
         <p:nvSpPr>
           <p:cNvPr id="2" name="Rectangle 1"/>
@@ -8447,6 +8314,7 @@
           <a:lstStyle/>
           <a:p>
             <a:pPr algn="ctr"/>
+            <a:endParaRPr/>
           </a:p>
         </p:txBody>
       </p:sp>
@@ -8533,7 +8401,7 @@
           </a:fontRef>
         </p:style>
         <p:txBody>
-          <a:bodyPr rtlCol="0" anchor="ctr" wrap="square" lIns="152400" rIns="152400" tIns="177800" bIns="101600"/>
+          <a:bodyPr wrap="square" lIns="152400" tIns="177800" rIns="152400" bIns="101600" rtlCol="0" anchor="ctr"/>
           <a:lstStyle/>
           <a:p>
             <a:pPr algn="ctr"/>
@@ -8648,6 +8516,7 @@
           <a:lstStyle/>
           <a:p>
             <a:pPr algn="ctr"/>
+            <a:endParaRPr/>
           </a:p>
         </p:txBody>
       </p:sp>
@@ -8691,7 +8560,7 @@
           </a:fontRef>
         </p:style>
         <p:txBody>
-          <a:bodyPr rtlCol="0" anchor="ctr" wrap="square" lIns="152400" rIns="152400" tIns="177800" bIns="101600"/>
+          <a:bodyPr wrap="square" lIns="152400" tIns="177800" rIns="152400" bIns="101600" rtlCol="0" anchor="ctr"/>
           <a:lstStyle/>
           <a:p>
             <a:pPr algn="ctr"/>
@@ -8806,6 +8675,7 @@
           <a:lstStyle/>
           <a:p>
             <a:pPr algn="ctr"/>
+            <a:endParaRPr/>
           </a:p>
         </p:txBody>
       </p:sp>
@@ -8849,7 +8719,7 @@
           </a:fontRef>
         </p:style>
         <p:txBody>
-          <a:bodyPr rtlCol="0" anchor="ctr" wrap="square" lIns="152400" rIns="152400" tIns="177800" bIns="101600"/>
+          <a:bodyPr wrap="square" lIns="152400" tIns="177800" rIns="152400" bIns="101600" rtlCol="0" anchor="ctr"/>
           <a:lstStyle/>
           <a:p>
             <a:pPr algn="ctr"/>
@@ -8964,6 +8834,7 @@
           <a:lstStyle/>
           <a:p>
             <a:pPr algn="ctr"/>
+            <a:endParaRPr/>
           </a:p>
         </p:txBody>
       </p:sp>
@@ -9007,7 +8878,7 @@
           </a:fontRef>
         </p:style>
         <p:txBody>
-          <a:bodyPr rtlCol="0" anchor="ctr" wrap="square" lIns="152400" rIns="152400" tIns="177800" bIns="101600"/>
+          <a:bodyPr wrap="square" lIns="152400" tIns="177800" rIns="152400" bIns="101600" rtlCol="0" anchor="ctr"/>
           <a:lstStyle/>
           <a:p>
             <a:pPr algn="ctr"/>
@@ -9122,6 +8993,7 @@
           <a:lstStyle/>
           <a:p>
             <a:pPr algn="ctr"/>
+            <a:endParaRPr/>
           </a:p>
         </p:txBody>
       </p:sp>
@@ -9163,7 +9035,7 @@
           </a:fontRef>
         </p:style>
         <p:txBody>
-          <a:bodyPr rtlCol="0" anchor="ctr" wrap="square" lIns="177800"/>
+          <a:bodyPr wrap="square" lIns="177800" rtlCol="0" anchor="ctr"/>
           <a:lstStyle/>
           <a:p>
             <a:pPr algn="ctr"/>
@@ -9228,7 +9100,7 @@
 </file>
 
 <file path=ppt/slides/slide2.xml><?xml version="1.0" encoding="utf-8"?>
-<p:sld xmlns:a="http://schemas.openxmlformats.org/drawingml/2006/main" xmlns:p="http://schemas.openxmlformats.org/presentationml/2006/main" xmlns:r="http://schemas.openxmlformats.org/officeDocument/2006/relationships">
+<p:sld xmlns:a="http://schemas.openxmlformats.org/drawingml/2006/main" xmlns:r="http://schemas.openxmlformats.org/officeDocument/2006/relationships" xmlns:p="http://schemas.openxmlformats.org/presentationml/2006/main">
   <p:cSld>
     <p:bg>
       <p:bgPr>
@@ -9244,7 +9116,14 @@
         <p:cNvGrpSpPr/>
         <p:nvPr/>
       </p:nvGrpSpPr>
-      <p:grpSpPr/>
+      <p:grpSpPr>
+        <a:xfrm>
+          <a:off x="0" y="0"/>
+          <a:ext cx="0" cy="0"/>
+          <a:chOff x="0" y="0"/>
+          <a:chExt cx="0" cy="0"/>
+        </a:xfrm>
+      </p:grpSpPr>
       <p:sp>
         <p:nvSpPr>
           <p:cNvPr id="2" name="Rectangle 1"/>
@@ -9285,6 +9164,7 @@
           <a:lstStyle/>
           <a:p>
             <a:pPr algn="ctr"/>
+            <a:endParaRPr/>
           </a:p>
         </p:txBody>
       </p:sp>
@@ -9516,7 +9396,7 @@
 </file>
 
 <file path=ppt/slides/slide3.xml><?xml version="1.0" encoding="utf-8"?>
-<p:sld xmlns:a="http://schemas.openxmlformats.org/drawingml/2006/main" xmlns:p="http://schemas.openxmlformats.org/presentationml/2006/main" xmlns:r="http://schemas.openxmlformats.org/officeDocument/2006/relationships">
+<p:sld xmlns:a="http://schemas.openxmlformats.org/drawingml/2006/main" xmlns:r="http://schemas.openxmlformats.org/officeDocument/2006/relationships" xmlns:p="http://schemas.openxmlformats.org/presentationml/2006/main">
   <p:cSld>
     <p:bg>
       <p:bgPr>
@@ -9532,7 +9412,14 @@
         <p:cNvGrpSpPr/>
         <p:nvPr/>
       </p:nvGrpSpPr>
-      <p:grpSpPr/>
+      <p:grpSpPr>
+        <a:xfrm>
+          <a:off x="0" y="0"/>
+          <a:ext cx="0" cy="0"/>
+          <a:chOff x="0" y="0"/>
+          <a:chExt cx="0" cy="0"/>
+        </a:xfrm>
+      </p:grpSpPr>
       <p:sp>
         <p:nvSpPr>
           <p:cNvPr id="2" name="Rectangle 1"/>
@@ -9573,6 +9460,7 @@
           <a:lstStyle/>
           <a:p>
             <a:pPr algn="ctr"/>
+            <a:endParaRPr/>
           </a:p>
         </p:txBody>
       </p:sp>
@@ -9804,7 +9692,7 @@
 </file>
 
 <file path=ppt/slides/slide4.xml><?xml version="1.0" encoding="utf-8"?>
-<p:sld xmlns:a="http://schemas.openxmlformats.org/drawingml/2006/main" xmlns:p="http://schemas.openxmlformats.org/presentationml/2006/main" xmlns:r="http://schemas.openxmlformats.org/officeDocument/2006/relationships">
+<p:sld xmlns:a="http://schemas.openxmlformats.org/drawingml/2006/main" xmlns:r="http://schemas.openxmlformats.org/officeDocument/2006/relationships" xmlns:p="http://schemas.openxmlformats.org/presentationml/2006/main">
   <p:cSld>
     <p:bg>
       <p:bgPr>
@@ -9820,7 +9708,14 @@
         <p:cNvGrpSpPr/>
         <p:nvPr/>
       </p:nvGrpSpPr>
-      <p:grpSpPr/>
+      <p:grpSpPr>
+        <a:xfrm>
+          <a:off x="0" y="0"/>
+          <a:ext cx="0" cy="0"/>
+          <a:chOff x="0" y="0"/>
+          <a:chExt cx="0" cy="0"/>
+        </a:xfrm>
+      </p:grpSpPr>
       <p:sp>
         <p:nvSpPr>
           <p:cNvPr id="2" name="Rectangle 1"/>
@@ -9861,6 +9756,7 @@
           <a:lstStyle/>
           <a:p>
             <a:pPr algn="ctr"/>
+            <a:endParaRPr/>
           </a:p>
         </p:txBody>
       </p:sp>
@@ -9943,7 +9839,7 @@
           </a:fontRef>
         </p:style>
         <p:txBody>
-          <a:bodyPr rtlCol="0" anchor="ctr" wrap="square"/>
+          <a:bodyPr wrap="square" rtlCol="0" anchor="ctr"/>
           <a:lstStyle/>
           <a:p>
             <a:pPr algn="ctr"/>
@@ -10077,7 +9973,7 @@
           </a:fontRef>
         </p:style>
         <p:txBody>
-          <a:bodyPr rtlCol="0" anchor="ctr" wrap="square"/>
+          <a:bodyPr wrap="square" rtlCol="0" anchor="ctr"/>
           <a:lstStyle/>
           <a:p>
             <a:pPr algn="ctr"/>
@@ -10217,7 +10113,7 @@
 </file>
 
 <file path=ppt/slides/slide5.xml><?xml version="1.0" encoding="utf-8"?>
-<p:sld xmlns:a="http://schemas.openxmlformats.org/drawingml/2006/main" xmlns:p="http://schemas.openxmlformats.org/presentationml/2006/main" xmlns:r="http://schemas.openxmlformats.org/officeDocument/2006/relationships">
+<p:sld xmlns:a="http://schemas.openxmlformats.org/drawingml/2006/main" xmlns:r="http://schemas.openxmlformats.org/officeDocument/2006/relationships" xmlns:p="http://schemas.openxmlformats.org/presentationml/2006/main">
   <p:cSld>
     <p:bg>
       <p:bgPr>
@@ -10233,7 +10129,14 @@
         <p:cNvGrpSpPr/>
         <p:nvPr/>
       </p:nvGrpSpPr>
-      <p:grpSpPr/>
+      <p:grpSpPr>
+        <a:xfrm>
+          <a:off x="0" y="0"/>
+          <a:ext cx="0" cy="0"/>
+          <a:chOff x="0" y="0"/>
+          <a:chExt cx="0" cy="0"/>
+        </a:xfrm>
+      </p:grpSpPr>
       <p:sp>
         <p:nvSpPr>
           <p:cNvPr id="2" name="Rectangle 1"/>
@@ -10274,6 +10177,7 @@
           <a:lstStyle/>
           <a:p>
             <a:pPr algn="ctr"/>
+            <a:endParaRPr/>
           </a:p>
         </p:txBody>
       </p:sp>
@@ -10339,9 +10243,27 @@
                 <a:tableStyleId>{5C22544A-7EE6-4342-B048-85BDC9FD1C3A}</a:tableStyleId>
               </a:tblPr>
               <a:tblGrid>
-                <a:gridCol w="2321603"/>
-                <a:gridCol w="7196969"/>
-                <a:gridCol w="1392961"/>
+                <a:gridCol w="2321603">
+                  <a:extLst>
+                    <a:ext uri="{9D8B030D-6E8A-4147-A177-3AD203B41FA5}">
+                      <a16:colId xmlns:a16="http://schemas.microsoft.com/office/drawing/2014/main" val="20000"/>
+                    </a:ext>
+                  </a:extLst>
+                </a:gridCol>
+                <a:gridCol w="7196969">
+                  <a:extLst>
+                    <a:ext uri="{9D8B030D-6E8A-4147-A177-3AD203B41FA5}">
+                      <a16:colId xmlns:a16="http://schemas.microsoft.com/office/drawing/2014/main" val="20001"/>
+                    </a:ext>
+                  </a:extLst>
+                </a:gridCol>
+                <a:gridCol w="1392961">
+                  <a:extLst>
+                    <a:ext uri="{9D8B030D-6E8A-4147-A177-3AD203B41FA5}">
+                      <a16:colId xmlns:a16="http://schemas.microsoft.com/office/drawing/2014/main" val="20002"/>
+                    </a:ext>
+                  </a:extLst>
+                </a:gridCol>
               </a:tblGrid>
               <a:tr h="457200">
                 <a:tc>
@@ -10407,11 +10329,16 @@
                     </a:solidFill>
                   </a:tcPr>
                 </a:tc>
+                <a:extLst>
+                  <a:ext uri="{0D108BD9-81ED-4DB2-BD59-A6C34878D82A}">
+                    <a16:rowId xmlns:a16="http://schemas.microsoft.com/office/drawing/2014/main" val="10000"/>
+                  </a:ext>
+                </a:extLst>
               </a:tr>
               <a:tr h="457200">
                 <a:tc>
                   <a:txBody>
-                    <a:bodyPr wrap="square"/>
+                    <a:bodyPr/>
                     <a:lstStyle/>
                     <a:p>
                       <a:r>
@@ -10432,7 +10359,7 @@
                 </a:tc>
                 <a:tc>
                   <a:txBody>
-                    <a:bodyPr wrap="square"/>
+                    <a:bodyPr/>
                     <a:lstStyle/>
                     <a:p>
                       <a:r>
@@ -10453,7 +10380,7 @@
                 </a:tc>
                 <a:tc>
                   <a:txBody>
-                    <a:bodyPr wrap="square"/>
+                    <a:bodyPr/>
                     <a:lstStyle/>
                     <a:p>
                       <a:r>
@@ -10472,11 +10399,16 @@
                     </a:solidFill>
                   </a:tcPr>
                 </a:tc>
+                <a:extLst>
+                  <a:ext uri="{0D108BD9-81ED-4DB2-BD59-A6C34878D82A}">
+                    <a16:rowId xmlns:a16="http://schemas.microsoft.com/office/drawing/2014/main" val="10001"/>
+                  </a:ext>
+                </a:extLst>
               </a:tr>
               <a:tr h="457200">
                 <a:tc>
                   <a:txBody>
-                    <a:bodyPr wrap="square"/>
+                    <a:bodyPr/>
                     <a:lstStyle/>
                     <a:p>
                       <a:r>
@@ -10497,7 +10429,7 @@
                 </a:tc>
                 <a:tc>
                   <a:txBody>
-                    <a:bodyPr wrap="square"/>
+                    <a:bodyPr/>
                     <a:lstStyle/>
                     <a:p>
                       <a:r>
@@ -10518,7 +10450,7 @@
                 </a:tc>
                 <a:tc>
                   <a:txBody>
-                    <a:bodyPr wrap="square"/>
+                    <a:bodyPr/>
                     <a:lstStyle/>
                     <a:p>
                       <a:r>
@@ -10537,11 +10469,16 @@
                     </a:solidFill>
                   </a:tcPr>
                 </a:tc>
+                <a:extLst>
+                  <a:ext uri="{0D108BD9-81ED-4DB2-BD59-A6C34878D82A}">
+                    <a16:rowId xmlns:a16="http://schemas.microsoft.com/office/drawing/2014/main" val="10002"/>
+                  </a:ext>
+                </a:extLst>
               </a:tr>
               <a:tr h="457200">
                 <a:tc>
                   <a:txBody>
-                    <a:bodyPr wrap="square"/>
+                    <a:bodyPr/>
                     <a:lstStyle/>
                     <a:p>
                       <a:r>
@@ -10562,7 +10499,7 @@
                 </a:tc>
                 <a:tc>
                   <a:txBody>
-                    <a:bodyPr wrap="square"/>
+                    <a:bodyPr/>
                     <a:lstStyle/>
                     <a:p>
                       <a:r>
@@ -10583,7 +10520,7 @@
                 </a:tc>
                 <a:tc>
                   <a:txBody>
-                    <a:bodyPr wrap="square"/>
+                    <a:bodyPr/>
                     <a:lstStyle/>
                     <a:p>
                       <a:r>
@@ -10602,11 +10539,16 @@
                     </a:solidFill>
                   </a:tcPr>
                 </a:tc>
+                <a:extLst>
+                  <a:ext uri="{0D108BD9-81ED-4DB2-BD59-A6C34878D82A}">
+                    <a16:rowId xmlns:a16="http://schemas.microsoft.com/office/drawing/2014/main" val="10003"/>
+                  </a:ext>
+                </a:extLst>
               </a:tr>
               <a:tr h="457200">
                 <a:tc>
                   <a:txBody>
-                    <a:bodyPr wrap="square"/>
+                    <a:bodyPr/>
                     <a:lstStyle/>
                     <a:p>
                       <a:r>
@@ -10627,7 +10569,7 @@
                 </a:tc>
                 <a:tc>
                   <a:txBody>
-                    <a:bodyPr wrap="square"/>
+                    <a:bodyPr/>
                     <a:lstStyle/>
                     <a:p>
                       <a:r>
@@ -10648,7 +10590,7 @@
                 </a:tc>
                 <a:tc>
                   <a:txBody>
-                    <a:bodyPr wrap="square"/>
+                    <a:bodyPr/>
                     <a:lstStyle/>
                     <a:p>
                       <a:r>
@@ -10667,11 +10609,16 @@
                     </a:solidFill>
                   </a:tcPr>
                 </a:tc>
+                <a:extLst>
+                  <a:ext uri="{0D108BD9-81ED-4DB2-BD59-A6C34878D82A}">
+                    <a16:rowId xmlns:a16="http://schemas.microsoft.com/office/drawing/2014/main" val="10004"/>
+                  </a:ext>
+                </a:extLst>
               </a:tr>
               <a:tr h="457200">
                 <a:tc>
                   <a:txBody>
-                    <a:bodyPr wrap="square"/>
+                    <a:bodyPr/>
                     <a:lstStyle/>
                     <a:p>
                       <a:r>
@@ -10692,7 +10639,7 @@
                 </a:tc>
                 <a:tc>
                   <a:txBody>
-                    <a:bodyPr wrap="square"/>
+                    <a:bodyPr/>
                     <a:lstStyle/>
                     <a:p>
                       <a:r>
@@ -10713,7 +10660,7 @@
                 </a:tc>
                 <a:tc>
                   <a:txBody>
-                    <a:bodyPr wrap="square"/>
+                    <a:bodyPr/>
                     <a:lstStyle/>
                     <a:p>
                       <a:r>
@@ -10732,11 +10679,16 @@
                     </a:solidFill>
                   </a:tcPr>
                 </a:tc>
+                <a:extLst>
+                  <a:ext uri="{0D108BD9-81ED-4DB2-BD59-A6C34878D82A}">
+                    <a16:rowId xmlns:a16="http://schemas.microsoft.com/office/drawing/2014/main" val="10005"/>
+                  </a:ext>
+                </a:extLst>
               </a:tr>
               <a:tr h="457200">
                 <a:tc>
                   <a:txBody>
-                    <a:bodyPr wrap="square"/>
+                    <a:bodyPr/>
                     <a:lstStyle/>
                     <a:p>
                       <a:r>
@@ -10757,7 +10709,7 @@
                 </a:tc>
                 <a:tc>
                   <a:txBody>
-                    <a:bodyPr wrap="square"/>
+                    <a:bodyPr/>
                     <a:lstStyle/>
                     <a:p>
                       <a:r>
@@ -10778,7 +10730,7 @@
                 </a:tc>
                 <a:tc>
                   <a:txBody>
-                    <a:bodyPr wrap="square"/>
+                    <a:bodyPr/>
                     <a:lstStyle/>
                     <a:p>
                       <a:r>
@@ -10797,11 +10749,16 @@
                     </a:solidFill>
                   </a:tcPr>
                 </a:tc>
+                <a:extLst>
+                  <a:ext uri="{0D108BD9-81ED-4DB2-BD59-A6C34878D82A}">
+                    <a16:rowId xmlns:a16="http://schemas.microsoft.com/office/drawing/2014/main" val="10006"/>
+                  </a:ext>
+                </a:extLst>
               </a:tr>
               <a:tr h="457200">
                 <a:tc>
                   <a:txBody>
-                    <a:bodyPr wrap="square"/>
+                    <a:bodyPr/>
                     <a:lstStyle/>
                     <a:p>
                       <a:r>
@@ -10822,7 +10779,7 @@
                 </a:tc>
                 <a:tc>
                   <a:txBody>
-                    <a:bodyPr wrap="square"/>
+                    <a:bodyPr/>
                     <a:lstStyle/>
                     <a:p>
                       <a:r>
@@ -10843,7 +10800,7 @@
                 </a:tc>
                 <a:tc>
                   <a:txBody>
-                    <a:bodyPr wrap="square"/>
+                    <a:bodyPr/>
                     <a:lstStyle/>
                     <a:p>
                       <a:r>
@@ -10862,11 +10819,16 @@
                     </a:solidFill>
                   </a:tcPr>
                 </a:tc>
+                <a:extLst>
+                  <a:ext uri="{0D108BD9-81ED-4DB2-BD59-A6C34878D82A}">
+                    <a16:rowId xmlns:a16="http://schemas.microsoft.com/office/drawing/2014/main" val="10007"/>
+                  </a:ext>
+                </a:extLst>
               </a:tr>
               <a:tr h="457200">
                 <a:tc>
                   <a:txBody>
-                    <a:bodyPr wrap="square"/>
+                    <a:bodyPr/>
                     <a:lstStyle/>
                     <a:p>
                       <a:r>
@@ -10887,7 +10849,7 @@
                 </a:tc>
                 <a:tc>
                   <a:txBody>
-                    <a:bodyPr wrap="square"/>
+                    <a:bodyPr/>
                     <a:lstStyle/>
                     <a:p>
                       <a:r>
@@ -10908,7 +10870,7 @@
                 </a:tc>
                 <a:tc>
                   <a:txBody>
-                    <a:bodyPr wrap="square"/>
+                    <a:bodyPr/>
                     <a:lstStyle/>
                     <a:p>
                       <a:r>
@@ -10927,11 +10889,16 @@
                     </a:solidFill>
                   </a:tcPr>
                 </a:tc>
+                <a:extLst>
+                  <a:ext uri="{0D108BD9-81ED-4DB2-BD59-A6C34878D82A}">
+                    <a16:rowId xmlns:a16="http://schemas.microsoft.com/office/drawing/2014/main" val="10008"/>
+                  </a:ext>
+                </a:extLst>
               </a:tr>
               <a:tr h="457200">
                 <a:tc>
                   <a:txBody>
-                    <a:bodyPr wrap="square"/>
+                    <a:bodyPr/>
                     <a:lstStyle/>
                     <a:p>
                       <a:r>
@@ -10952,7 +10919,7 @@
                 </a:tc>
                 <a:tc>
                   <a:txBody>
-                    <a:bodyPr wrap="square"/>
+                    <a:bodyPr/>
                     <a:lstStyle/>
                     <a:p>
                       <a:r>
@@ -10973,7 +10940,7 @@
                 </a:tc>
                 <a:tc>
                   <a:txBody>
-                    <a:bodyPr wrap="square"/>
+                    <a:bodyPr/>
                     <a:lstStyle/>
                     <a:p>
                       <a:r>
@@ -10992,6 +10959,11 @@
                     </a:solidFill>
                   </a:tcPr>
                 </a:tc>
+                <a:extLst>
+                  <a:ext uri="{0D108BD9-81ED-4DB2-BD59-A6C34878D82A}">
+                    <a16:rowId xmlns:a16="http://schemas.microsoft.com/office/drawing/2014/main" val="10009"/>
+                  </a:ext>
+                </a:extLst>
               </a:tr>
             </a:tbl>
           </a:graphicData>
@@ -11039,7 +11011,7 @@
 </file>
 
 <file path=ppt/slides/slide6.xml><?xml version="1.0" encoding="utf-8"?>
-<p:sld xmlns:a="http://schemas.openxmlformats.org/drawingml/2006/main" xmlns:p="http://schemas.openxmlformats.org/presentationml/2006/main" xmlns:r="http://schemas.openxmlformats.org/officeDocument/2006/relationships">
+<p:sld xmlns:a="http://schemas.openxmlformats.org/drawingml/2006/main" xmlns:r="http://schemas.openxmlformats.org/officeDocument/2006/relationships" xmlns:p="http://schemas.openxmlformats.org/presentationml/2006/main">
   <p:cSld>
     <p:bg>
       <p:bgPr>
@@ -11055,7 +11027,14 @@
         <p:cNvGrpSpPr/>
         <p:nvPr/>
       </p:nvGrpSpPr>
-      <p:grpSpPr/>
+      <p:grpSpPr>
+        <a:xfrm>
+          <a:off x="0" y="0"/>
+          <a:ext cx="0" cy="0"/>
+          <a:chOff x="0" y="0"/>
+          <a:chExt cx="0" cy="0"/>
+        </a:xfrm>
+      </p:grpSpPr>
       <p:sp>
         <p:nvSpPr>
           <p:cNvPr id="2" name="Rectangle 1"/>
@@ -11096,6 +11075,7 @@
           <a:lstStyle/>
           <a:p>
             <a:pPr algn="ctr"/>
+            <a:endParaRPr/>
           </a:p>
         </p:txBody>
       </p:sp>
@@ -11161,9 +11141,27 @@
                 <a:tableStyleId>{5C22544A-7EE6-4342-B048-85BDC9FD1C3A}</a:tableStyleId>
               </a:tblPr>
               <a:tblGrid>
-                <a:gridCol w="2500560"/>
-                <a:gridCol w="7047033"/>
-                <a:gridCol w="1363941"/>
+                <a:gridCol w="2500560">
+                  <a:extLst>
+                    <a:ext uri="{9D8B030D-6E8A-4147-A177-3AD203B41FA5}">
+                      <a16:colId xmlns:a16="http://schemas.microsoft.com/office/drawing/2014/main" val="20000"/>
+                    </a:ext>
+                  </a:extLst>
+                </a:gridCol>
+                <a:gridCol w="7047033">
+                  <a:extLst>
+                    <a:ext uri="{9D8B030D-6E8A-4147-A177-3AD203B41FA5}">
+                      <a16:colId xmlns:a16="http://schemas.microsoft.com/office/drawing/2014/main" val="20001"/>
+                    </a:ext>
+                  </a:extLst>
+                </a:gridCol>
+                <a:gridCol w="1363941">
+                  <a:extLst>
+                    <a:ext uri="{9D8B030D-6E8A-4147-A177-3AD203B41FA5}">
+                      <a16:colId xmlns:a16="http://schemas.microsoft.com/office/drawing/2014/main" val="20002"/>
+                    </a:ext>
+                  </a:extLst>
+                </a:gridCol>
               </a:tblGrid>
               <a:tr h="457200">
                 <a:tc>
@@ -11229,11 +11227,16 @@
                     </a:solidFill>
                   </a:tcPr>
                 </a:tc>
+                <a:extLst>
+                  <a:ext uri="{0D108BD9-81ED-4DB2-BD59-A6C34878D82A}">
+                    <a16:rowId xmlns:a16="http://schemas.microsoft.com/office/drawing/2014/main" val="10000"/>
+                  </a:ext>
+                </a:extLst>
               </a:tr>
               <a:tr h="457200">
                 <a:tc>
                   <a:txBody>
-                    <a:bodyPr wrap="square"/>
+                    <a:bodyPr/>
                     <a:lstStyle/>
                     <a:p>
                       <a:r>
@@ -11254,7 +11257,7 @@
                 </a:tc>
                 <a:tc>
                   <a:txBody>
-                    <a:bodyPr wrap="square"/>
+                    <a:bodyPr/>
                     <a:lstStyle/>
                     <a:p>
                       <a:r>
@@ -11275,7 +11278,7 @@
                 </a:tc>
                 <a:tc>
                   <a:txBody>
-                    <a:bodyPr wrap="square"/>
+                    <a:bodyPr/>
                     <a:lstStyle/>
                     <a:p>
                       <a:r>
@@ -11294,11 +11297,16 @@
                     </a:solidFill>
                   </a:tcPr>
                 </a:tc>
+                <a:extLst>
+                  <a:ext uri="{0D108BD9-81ED-4DB2-BD59-A6C34878D82A}">
+                    <a16:rowId xmlns:a16="http://schemas.microsoft.com/office/drawing/2014/main" val="10001"/>
+                  </a:ext>
+                </a:extLst>
               </a:tr>
               <a:tr h="457200">
                 <a:tc>
                   <a:txBody>
-                    <a:bodyPr wrap="square"/>
+                    <a:bodyPr/>
                     <a:lstStyle/>
                     <a:p>
                       <a:r>
@@ -11319,7 +11327,7 @@
                 </a:tc>
                 <a:tc>
                   <a:txBody>
-                    <a:bodyPr wrap="square"/>
+                    <a:bodyPr/>
                     <a:lstStyle/>
                     <a:p>
                       <a:r>
@@ -11340,7 +11348,7 @@
                 </a:tc>
                 <a:tc>
                   <a:txBody>
-                    <a:bodyPr wrap="square"/>
+                    <a:bodyPr/>
                     <a:lstStyle/>
                     <a:p>
                       <a:r>
@@ -11359,11 +11367,16 @@
                     </a:solidFill>
                   </a:tcPr>
                 </a:tc>
+                <a:extLst>
+                  <a:ext uri="{0D108BD9-81ED-4DB2-BD59-A6C34878D82A}">
+                    <a16:rowId xmlns:a16="http://schemas.microsoft.com/office/drawing/2014/main" val="10002"/>
+                  </a:ext>
+                </a:extLst>
               </a:tr>
               <a:tr h="457200">
                 <a:tc>
                   <a:txBody>
-                    <a:bodyPr wrap="square"/>
+                    <a:bodyPr/>
                     <a:lstStyle/>
                     <a:p>
                       <a:r>
@@ -11384,7 +11397,7 @@
                 </a:tc>
                 <a:tc>
                   <a:txBody>
-                    <a:bodyPr wrap="square"/>
+                    <a:bodyPr/>
                     <a:lstStyle/>
                     <a:p>
                       <a:r>
@@ -11405,7 +11418,7 @@
                 </a:tc>
                 <a:tc>
                   <a:txBody>
-                    <a:bodyPr wrap="square"/>
+                    <a:bodyPr/>
                     <a:lstStyle/>
                     <a:p>
                       <a:r>
@@ -11424,11 +11437,16 @@
                     </a:solidFill>
                   </a:tcPr>
                 </a:tc>
+                <a:extLst>
+                  <a:ext uri="{0D108BD9-81ED-4DB2-BD59-A6C34878D82A}">
+                    <a16:rowId xmlns:a16="http://schemas.microsoft.com/office/drawing/2014/main" val="10003"/>
+                  </a:ext>
+                </a:extLst>
               </a:tr>
               <a:tr h="457200">
                 <a:tc>
                   <a:txBody>
-                    <a:bodyPr wrap="square"/>
+                    <a:bodyPr/>
                     <a:lstStyle/>
                     <a:p>
                       <a:r>
@@ -11449,7 +11467,7 @@
                 </a:tc>
                 <a:tc>
                   <a:txBody>
-                    <a:bodyPr wrap="square"/>
+                    <a:bodyPr/>
                     <a:lstStyle/>
                     <a:p>
                       <a:r>
@@ -11470,7 +11488,7 @@
                 </a:tc>
                 <a:tc>
                   <a:txBody>
-                    <a:bodyPr wrap="square"/>
+                    <a:bodyPr/>
                     <a:lstStyle/>
                     <a:p>
                       <a:r>
@@ -11489,11 +11507,16 @@
                     </a:solidFill>
                   </a:tcPr>
                 </a:tc>
+                <a:extLst>
+                  <a:ext uri="{0D108BD9-81ED-4DB2-BD59-A6C34878D82A}">
+                    <a16:rowId xmlns:a16="http://schemas.microsoft.com/office/drawing/2014/main" val="10004"/>
+                  </a:ext>
+                </a:extLst>
               </a:tr>
               <a:tr h="457200">
                 <a:tc>
                   <a:txBody>
-                    <a:bodyPr wrap="square"/>
+                    <a:bodyPr/>
                     <a:lstStyle/>
                     <a:p>
                       <a:r>
@@ -11514,7 +11537,7 @@
                 </a:tc>
                 <a:tc>
                   <a:txBody>
-                    <a:bodyPr wrap="square"/>
+                    <a:bodyPr/>
                     <a:lstStyle/>
                     <a:p>
                       <a:r>
@@ -11535,7 +11558,7 @@
                 </a:tc>
                 <a:tc>
                   <a:txBody>
-                    <a:bodyPr wrap="square"/>
+                    <a:bodyPr/>
                     <a:lstStyle/>
                     <a:p>
                       <a:r>
@@ -11554,11 +11577,16 @@
                     </a:solidFill>
                   </a:tcPr>
                 </a:tc>
+                <a:extLst>
+                  <a:ext uri="{0D108BD9-81ED-4DB2-BD59-A6C34878D82A}">
+                    <a16:rowId xmlns:a16="http://schemas.microsoft.com/office/drawing/2014/main" val="10005"/>
+                  </a:ext>
+                </a:extLst>
               </a:tr>
               <a:tr h="457200">
                 <a:tc>
                   <a:txBody>
-                    <a:bodyPr wrap="square"/>
+                    <a:bodyPr/>
                     <a:lstStyle/>
                     <a:p>
                       <a:r>
@@ -11579,7 +11607,7 @@
                 </a:tc>
                 <a:tc>
                   <a:txBody>
-                    <a:bodyPr wrap="square"/>
+                    <a:bodyPr/>
                     <a:lstStyle/>
                     <a:p>
                       <a:r>
@@ -11600,7 +11628,7 @@
                 </a:tc>
                 <a:tc>
                   <a:txBody>
-                    <a:bodyPr wrap="square"/>
+                    <a:bodyPr/>
                     <a:lstStyle/>
                     <a:p>
                       <a:r>
@@ -11619,11 +11647,16 @@
                     </a:solidFill>
                   </a:tcPr>
                 </a:tc>
+                <a:extLst>
+                  <a:ext uri="{0D108BD9-81ED-4DB2-BD59-A6C34878D82A}">
+                    <a16:rowId xmlns:a16="http://schemas.microsoft.com/office/drawing/2014/main" val="10006"/>
+                  </a:ext>
+                </a:extLst>
               </a:tr>
               <a:tr h="457200">
                 <a:tc>
                   <a:txBody>
-                    <a:bodyPr wrap="square"/>
+                    <a:bodyPr/>
                     <a:lstStyle/>
                     <a:p>
                       <a:r>
@@ -11644,7 +11677,7 @@
                 </a:tc>
                 <a:tc>
                   <a:txBody>
-                    <a:bodyPr wrap="square"/>
+                    <a:bodyPr/>
                     <a:lstStyle/>
                     <a:p>
                       <a:r>
@@ -11665,7 +11698,7 @@
                 </a:tc>
                 <a:tc>
                   <a:txBody>
-                    <a:bodyPr wrap="square"/>
+                    <a:bodyPr/>
                     <a:lstStyle/>
                     <a:p>
                       <a:r>
@@ -11684,6 +11717,11 @@
                     </a:solidFill>
                   </a:tcPr>
                 </a:tc>
+                <a:extLst>
+                  <a:ext uri="{0D108BD9-81ED-4DB2-BD59-A6C34878D82A}">
+                    <a16:rowId xmlns:a16="http://schemas.microsoft.com/office/drawing/2014/main" val="10007"/>
+                  </a:ext>
+                </a:extLst>
               </a:tr>
             </a:tbl>
           </a:graphicData>
@@ -11731,7 +11769,7 @@
 </file>
 
 <file path=ppt/slides/slide7.xml><?xml version="1.0" encoding="utf-8"?>
-<p:sld xmlns:a="http://schemas.openxmlformats.org/drawingml/2006/main" xmlns:p="http://schemas.openxmlformats.org/presentationml/2006/main" xmlns:r="http://schemas.openxmlformats.org/officeDocument/2006/relationships">
+<p:sld xmlns:a="http://schemas.openxmlformats.org/drawingml/2006/main" xmlns:r="http://schemas.openxmlformats.org/officeDocument/2006/relationships" xmlns:p="http://schemas.openxmlformats.org/presentationml/2006/main">
   <p:cSld>
     <p:bg>
       <p:bgPr>
@@ -11747,7 +11785,14 @@
         <p:cNvGrpSpPr/>
         <p:nvPr/>
       </p:nvGrpSpPr>
-      <p:grpSpPr/>
+      <p:grpSpPr>
+        <a:xfrm>
+          <a:off x="0" y="0"/>
+          <a:ext cx="0" cy="0"/>
+          <a:chOff x="0" y="0"/>
+          <a:chExt cx="0" cy="0"/>
+        </a:xfrm>
+      </p:grpSpPr>
       <p:sp>
         <p:nvSpPr>
           <p:cNvPr id="2" name="Rectangle 1"/>
@@ -11788,6 +11833,7 @@
           <a:lstStyle/>
           <a:p>
             <a:pPr algn="ctr"/>
+            <a:endParaRPr/>
           </a:p>
         </p:txBody>
       </p:sp>
@@ -11843,7 +11889,7 @@
           <p:nvPr/>
         </p:nvPicPr>
         <p:blipFill>
-          <a:blip r:embed="rId2"/>
+          <a:blip r:embed="rId3"/>
           <a:stretch>
             <a:fillRect/>
           </a:stretch>
@@ -11900,7 +11946,7 @@
 </file>
 
 <file path=ppt/slides/slide8.xml><?xml version="1.0" encoding="utf-8"?>
-<p:sld xmlns:a="http://schemas.openxmlformats.org/drawingml/2006/main" xmlns:p="http://schemas.openxmlformats.org/presentationml/2006/main" xmlns:r="http://schemas.openxmlformats.org/officeDocument/2006/relationships">
+<p:sld xmlns:a="http://schemas.openxmlformats.org/drawingml/2006/main" xmlns:r="http://schemas.openxmlformats.org/officeDocument/2006/relationships" xmlns:p="http://schemas.openxmlformats.org/presentationml/2006/main">
   <p:cSld>
     <p:bg>
       <p:bgPr>
@@ -11916,7 +11962,14 @@
         <p:cNvGrpSpPr/>
         <p:nvPr/>
       </p:nvGrpSpPr>
-      <p:grpSpPr/>
+      <p:grpSpPr>
+        <a:xfrm>
+          <a:off x="0" y="0"/>
+          <a:ext cx="0" cy="0"/>
+          <a:chOff x="0" y="0"/>
+          <a:chExt cx="0" cy="0"/>
+        </a:xfrm>
+      </p:grpSpPr>
       <p:sp>
         <p:nvSpPr>
           <p:cNvPr id="2" name="Rectangle 1"/>
@@ -11957,6 +12010,7 @@
           <a:lstStyle/>
           <a:p>
             <a:pPr algn="ctr"/>
+            <a:endParaRPr/>
           </a:p>
         </p:txBody>
       </p:sp>
@@ -12022,9 +12076,27 @@
                 <a:tableStyleId>{5C22544A-7EE6-4342-B048-85BDC9FD1C3A}</a:tableStyleId>
               </a:tblPr>
               <a:tblGrid>
-                <a:gridCol w="2182307"/>
-                <a:gridCol w="4801075"/>
-                <a:gridCol w="3928152"/>
+                <a:gridCol w="2182307">
+                  <a:extLst>
+                    <a:ext uri="{9D8B030D-6E8A-4147-A177-3AD203B41FA5}">
+                      <a16:colId xmlns:a16="http://schemas.microsoft.com/office/drawing/2014/main" val="20000"/>
+                    </a:ext>
+                  </a:extLst>
+                </a:gridCol>
+                <a:gridCol w="4801075">
+                  <a:extLst>
+                    <a:ext uri="{9D8B030D-6E8A-4147-A177-3AD203B41FA5}">
+                      <a16:colId xmlns:a16="http://schemas.microsoft.com/office/drawing/2014/main" val="20001"/>
+                    </a:ext>
+                  </a:extLst>
+                </a:gridCol>
+                <a:gridCol w="3928152">
+                  <a:extLst>
+                    <a:ext uri="{9D8B030D-6E8A-4147-A177-3AD203B41FA5}">
+                      <a16:colId xmlns:a16="http://schemas.microsoft.com/office/drawing/2014/main" val="20002"/>
+                    </a:ext>
+                  </a:extLst>
+                </a:gridCol>
               </a:tblGrid>
               <a:tr h="457200">
                 <a:tc>
@@ -12090,11 +12162,16 @@
                     </a:solidFill>
                   </a:tcPr>
                 </a:tc>
+                <a:extLst>
+                  <a:ext uri="{0D108BD9-81ED-4DB2-BD59-A6C34878D82A}">
+                    <a16:rowId xmlns:a16="http://schemas.microsoft.com/office/drawing/2014/main" val="10000"/>
+                  </a:ext>
+                </a:extLst>
               </a:tr>
               <a:tr h="457200">
                 <a:tc>
                   <a:txBody>
-                    <a:bodyPr wrap="square"/>
+                    <a:bodyPr/>
                     <a:lstStyle/>
                     <a:p>
                       <a:r>
@@ -12115,7 +12192,7 @@
                 </a:tc>
                 <a:tc>
                   <a:txBody>
-                    <a:bodyPr wrap="square"/>
+                    <a:bodyPr/>
                     <a:lstStyle/>
                     <a:p>
                       <a:r>
@@ -12136,7 +12213,7 @@
                 </a:tc>
                 <a:tc>
                   <a:txBody>
-                    <a:bodyPr wrap="square"/>
+                    <a:bodyPr/>
                     <a:lstStyle/>
                     <a:p>
                       <a:r>
@@ -12155,11 +12232,16 @@
                     </a:solidFill>
                   </a:tcPr>
                 </a:tc>
+                <a:extLst>
+                  <a:ext uri="{0D108BD9-81ED-4DB2-BD59-A6C34878D82A}">
+                    <a16:rowId xmlns:a16="http://schemas.microsoft.com/office/drawing/2014/main" val="10001"/>
+                  </a:ext>
+                </a:extLst>
               </a:tr>
               <a:tr h="457200">
                 <a:tc>
                   <a:txBody>
-                    <a:bodyPr wrap="square"/>
+                    <a:bodyPr/>
                     <a:lstStyle/>
                     <a:p>
                       <a:r>
@@ -12180,7 +12262,7 @@
                 </a:tc>
                 <a:tc>
                   <a:txBody>
-                    <a:bodyPr wrap="square"/>
+                    <a:bodyPr/>
                     <a:lstStyle/>
                     <a:p>
                       <a:r>
@@ -12201,7 +12283,7 @@
                 </a:tc>
                 <a:tc>
                   <a:txBody>
-                    <a:bodyPr wrap="square"/>
+                    <a:bodyPr/>
                     <a:lstStyle/>
                     <a:p>
                       <a:r>
@@ -12220,11 +12302,16 @@
                     </a:solidFill>
                   </a:tcPr>
                 </a:tc>
+                <a:extLst>
+                  <a:ext uri="{0D108BD9-81ED-4DB2-BD59-A6C34878D82A}">
+                    <a16:rowId xmlns:a16="http://schemas.microsoft.com/office/drawing/2014/main" val="10002"/>
+                  </a:ext>
+                </a:extLst>
               </a:tr>
               <a:tr h="457200">
                 <a:tc>
                   <a:txBody>
-                    <a:bodyPr wrap="square"/>
+                    <a:bodyPr/>
                     <a:lstStyle/>
                     <a:p>
                       <a:r>
@@ -12245,7 +12332,7 @@
                 </a:tc>
                 <a:tc>
                   <a:txBody>
-                    <a:bodyPr wrap="square"/>
+                    <a:bodyPr/>
                     <a:lstStyle/>
                     <a:p>
                       <a:r>
@@ -12266,7 +12353,7 @@
                 </a:tc>
                 <a:tc>
                   <a:txBody>
-                    <a:bodyPr wrap="square"/>
+                    <a:bodyPr/>
                     <a:lstStyle/>
                     <a:p>
                       <a:r>
@@ -12285,11 +12372,16 @@
                     </a:solidFill>
                   </a:tcPr>
                 </a:tc>
+                <a:extLst>
+                  <a:ext uri="{0D108BD9-81ED-4DB2-BD59-A6C34878D82A}">
+                    <a16:rowId xmlns:a16="http://schemas.microsoft.com/office/drawing/2014/main" val="10003"/>
+                  </a:ext>
+                </a:extLst>
               </a:tr>
               <a:tr h="457200">
                 <a:tc>
                   <a:txBody>
-                    <a:bodyPr wrap="square"/>
+                    <a:bodyPr/>
                     <a:lstStyle/>
                     <a:p>
                       <a:r>
@@ -12310,7 +12402,7 @@
                 </a:tc>
                 <a:tc>
                   <a:txBody>
-                    <a:bodyPr wrap="square"/>
+                    <a:bodyPr/>
                     <a:lstStyle/>
                     <a:p>
                       <a:r>
@@ -12331,7 +12423,7 @@
                 </a:tc>
                 <a:tc>
                   <a:txBody>
-                    <a:bodyPr wrap="square"/>
+                    <a:bodyPr/>
                     <a:lstStyle/>
                     <a:p>
                       <a:r>
@@ -12350,11 +12442,16 @@
                     </a:solidFill>
                   </a:tcPr>
                 </a:tc>
+                <a:extLst>
+                  <a:ext uri="{0D108BD9-81ED-4DB2-BD59-A6C34878D82A}">
+                    <a16:rowId xmlns:a16="http://schemas.microsoft.com/office/drawing/2014/main" val="10004"/>
+                  </a:ext>
+                </a:extLst>
               </a:tr>
               <a:tr h="457200">
                 <a:tc>
                   <a:txBody>
-                    <a:bodyPr wrap="square"/>
+                    <a:bodyPr/>
                     <a:lstStyle/>
                     <a:p>
                       <a:r>
@@ -12375,7 +12472,7 @@
                 </a:tc>
                 <a:tc>
                   <a:txBody>
-                    <a:bodyPr wrap="square"/>
+                    <a:bodyPr/>
                     <a:lstStyle/>
                     <a:p>
                       <a:r>
@@ -12396,7 +12493,7 @@
                 </a:tc>
                 <a:tc>
                   <a:txBody>
-                    <a:bodyPr wrap="square"/>
+                    <a:bodyPr/>
                     <a:lstStyle/>
                     <a:p>
                       <a:r>
@@ -12415,11 +12512,16 @@
                     </a:solidFill>
                   </a:tcPr>
                 </a:tc>
+                <a:extLst>
+                  <a:ext uri="{0D108BD9-81ED-4DB2-BD59-A6C34878D82A}">
+                    <a16:rowId xmlns:a16="http://schemas.microsoft.com/office/drawing/2014/main" val="10005"/>
+                  </a:ext>
+                </a:extLst>
               </a:tr>
               <a:tr h="457200">
                 <a:tc>
                   <a:txBody>
-                    <a:bodyPr wrap="square"/>
+                    <a:bodyPr/>
                     <a:lstStyle/>
                     <a:p>
                       <a:r>
@@ -12440,7 +12542,7 @@
                 </a:tc>
                 <a:tc>
                   <a:txBody>
-                    <a:bodyPr wrap="square"/>
+                    <a:bodyPr/>
                     <a:lstStyle/>
                     <a:p>
                       <a:r>
@@ -12461,7 +12563,7 @@
                 </a:tc>
                 <a:tc>
                   <a:txBody>
-                    <a:bodyPr wrap="square"/>
+                    <a:bodyPr/>
                     <a:lstStyle/>
                     <a:p>
                       <a:r>
@@ -12480,11 +12582,16 @@
                     </a:solidFill>
                   </a:tcPr>
                 </a:tc>
+                <a:extLst>
+                  <a:ext uri="{0D108BD9-81ED-4DB2-BD59-A6C34878D82A}">
+                    <a16:rowId xmlns:a16="http://schemas.microsoft.com/office/drawing/2014/main" val="10006"/>
+                  </a:ext>
+                </a:extLst>
               </a:tr>
               <a:tr h="457200">
                 <a:tc>
                   <a:txBody>
-                    <a:bodyPr wrap="square"/>
+                    <a:bodyPr/>
                     <a:lstStyle/>
                     <a:p>
                       <a:r>
@@ -12505,7 +12612,7 @@
                 </a:tc>
                 <a:tc>
                   <a:txBody>
-                    <a:bodyPr wrap="square"/>
+                    <a:bodyPr/>
                     <a:lstStyle/>
                     <a:p>
                       <a:r>
@@ -12526,7 +12633,7 @@
                 </a:tc>
                 <a:tc>
                   <a:txBody>
-                    <a:bodyPr wrap="square"/>
+                    <a:bodyPr/>
                     <a:lstStyle/>
                     <a:p>
                       <a:r>
@@ -12545,11 +12652,16 @@
                     </a:solidFill>
                   </a:tcPr>
                 </a:tc>
+                <a:extLst>
+                  <a:ext uri="{0D108BD9-81ED-4DB2-BD59-A6C34878D82A}">
+                    <a16:rowId xmlns:a16="http://schemas.microsoft.com/office/drawing/2014/main" val="10007"/>
+                  </a:ext>
+                </a:extLst>
               </a:tr>
               <a:tr h="457200">
                 <a:tc>
                   <a:txBody>
-                    <a:bodyPr wrap="square"/>
+                    <a:bodyPr/>
                     <a:lstStyle/>
                     <a:p>
                       <a:r>
@@ -12570,7 +12682,7 @@
                 </a:tc>
                 <a:tc>
                   <a:txBody>
-                    <a:bodyPr wrap="square"/>
+                    <a:bodyPr/>
                     <a:lstStyle/>
                     <a:p>
                       <a:r>
@@ -12591,7 +12703,7 @@
                 </a:tc>
                 <a:tc>
                   <a:txBody>
-                    <a:bodyPr wrap="square"/>
+                    <a:bodyPr/>
                     <a:lstStyle/>
                     <a:p>
                       <a:r>
@@ -12610,6 +12722,11 @@
                     </a:solidFill>
                   </a:tcPr>
                 </a:tc>
+                <a:extLst>
+                  <a:ext uri="{0D108BD9-81ED-4DB2-BD59-A6C34878D82A}">
+                    <a16:rowId xmlns:a16="http://schemas.microsoft.com/office/drawing/2014/main" val="10008"/>
+                  </a:ext>
+                </a:extLst>
               </a:tr>
             </a:tbl>
           </a:graphicData>
@@ -12657,7 +12774,7 @@
 </file>
 
 <file path=ppt/slides/slide9.xml><?xml version="1.0" encoding="utf-8"?>
-<p:sld xmlns:a="http://schemas.openxmlformats.org/drawingml/2006/main" xmlns:p="http://schemas.openxmlformats.org/presentationml/2006/main" xmlns:r="http://schemas.openxmlformats.org/officeDocument/2006/relationships">
+<p:sld xmlns:a="http://schemas.openxmlformats.org/drawingml/2006/main" xmlns:r="http://schemas.openxmlformats.org/officeDocument/2006/relationships" xmlns:p="http://schemas.openxmlformats.org/presentationml/2006/main">
   <p:cSld>
     <p:bg>
       <p:bgPr>
@@ -12673,7 +12790,14 @@
         <p:cNvGrpSpPr/>
         <p:nvPr/>
       </p:nvGrpSpPr>
-      <p:grpSpPr/>
+      <p:grpSpPr>
+        <a:xfrm>
+          <a:off x="0" y="0"/>
+          <a:ext cx="0" cy="0"/>
+          <a:chOff x="0" y="0"/>
+          <a:chExt cx="0" cy="0"/>
+        </a:xfrm>
+      </p:grpSpPr>
       <p:sp>
         <p:nvSpPr>
           <p:cNvPr id="2" name="Rectangle 1"/>
@@ -12714,6 +12838,7 @@
           <a:lstStyle/>
           <a:p>
             <a:pPr algn="ctr"/>
+            <a:endParaRPr/>
           </a:p>
         </p:txBody>
       </p:sp>
@@ -12766,11 +12891,17 @@
           <p:cNvGraphicFramePr>
             <a:graphicFrameLocks noGrp="1"/>
           </p:cNvGraphicFramePr>
-          <p:nvPr/>
+          <p:nvPr>
+            <p:extLst>
+              <p:ext uri="{D42A27DB-BD31-4B8C-83A1-F6EECF244321}">
+                <p14:modId xmlns:p14="http://schemas.microsoft.com/office/powerpoint/2010/main" val="2451558869"/>
+              </p:ext>
+            </p:extLst>
+          </p:nvPr>
         </p:nvGraphicFramePr>
         <p:xfrm>
-          <a:off x="640080" y="1417320"/>
-          <a:ext cx="10911534" cy="1828800"/>
+          <a:off x="640233" y="1966612"/>
+          <a:ext cx="10911534" cy="3201705"/>
         </p:xfrm>
         <a:graphic>
           <a:graphicData uri="http://schemas.openxmlformats.org/drawingml/2006/table">
@@ -12779,19 +12910,43 @@
                 <a:tableStyleId>{5C22544A-7EE6-4342-B048-85BDC9FD1C3A}</a:tableStyleId>
               </a:tblPr>
               <a:tblGrid>
-                <a:gridCol w="2182307"/>
-                <a:gridCol w="2836999"/>
-                <a:gridCol w="2836999"/>
-                <a:gridCol w="3055229"/>
+                <a:gridCol w="2182307">
+                  <a:extLst>
+                    <a:ext uri="{9D8B030D-6E8A-4147-A177-3AD203B41FA5}">
+                      <a16:colId xmlns:a16="http://schemas.microsoft.com/office/drawing/2014/main" val="20000"/>
+                    </a:ext>
+                  </a:extLst>
+                </a:gridCol>
+                <a:gridCol w="2836999">
+                  <a:extLst>
+                    <a:ext uri="{9D8B030D-6E8A-4147-A177-3AD203B41FA5}">
+                      <a16:colId xmlns:a16="http://schemas.microsoft.com/office/drawing/2014/main" val="20001"/>
+                    </a:ext>
+                  </a:extLst>
+                </a:gridCol>
+                <a:gridCol w="2836999">
+                  <a:extLst>
+                    <a:ext uri="{9D8B030D-6E8A-4147-A177-3AD203B41FA5}">
+                      <a16:colId xmlns:a16="http://schemas.microsoft.com/office/drawing/2014/main" val="20002"/>
+                    </a:ext>
+                  </a:extLst>
+                </a:gridCol>
+                <a:gridCol w="3055229">
+                  <a:extLst>
+                    <a:ext uri="{9D8B030D-6E8A-4147-A177-3AD203B41FA5}">
+                      <a16:colId xmlns:a16="http://schemas.microsoft.com/office/drawing/2014/main" val="20003"/>
+                    </a:ext>
+                  </a:extLst>
+                </a:gridCol>
               </a:tblGrid>
-              <a:tr h="457200">
+              <a:tr h="484632">
                 <a:tc>
                   <a:txBody>
                     <a:bodyPr/>
                     <a:lstStyle/>
                     <a:p>
                       <a:r>
-                        <a:rPr sz="1300" b="1">
+                        <a:rPr sz="1300" b="1" dirty="0">
                           <a:solidFill>
                             <a:srgbClr val="FFFFFF"/>
                           </a:solidFill>
@@ -12812,7 +12967,7 @@
                     <a:lstStyle/>
                     <a:p>
                       <a:r>
-                        <a:rPr sz="1300" b="1">
+                        <a:rPr sz="1300" b="1" dirty="0">
                           <a:solidFill>
                             <a:srgbClr val="FFFFFF"/>
                           </a:solidFill>
@@ -12869,11 +13024,16 @@
                     </a:solidFill>
                   </a:tcPr>
                 </a:tc>
+                <a:extLst>
+                  <a:ext uri="{0D108BD9-81ED-4DB2-BD59-A6C34878D82A}">
+                    <a16:rowId xmlns:a16="http://schemas.microsoft.com/office/drawing/2014/main" val="10000"/>
+                  </a:ext>
+                </a:extLst>
               </a:tr>
-              <a:tr h="457200">
+              <a:tr h="905691">
                 <a:tc>
                   <a:txBody>
-                    <a:bodyPr wrap="square"/>
+                    <a:bodyPr/>
                     <a:lstStyle/>
                     <a:p>
                       <a:r>
@@ -12894,7 +13054,7 @@
                 </a:tc>
                 <a:tc>
                   <a:txBody>
-                    <a:bodyPr wrap="square"/>
+                    <a:bodyPr/>
                     <a:lstStyle/>
                     <a:p>
                       <a:r>
@@ -12924,7 +13084,7 @@
                 </a:tc>
                 <a:tc>
                   <a:txBody>
-                    <a:bodyPr wrap="square"/>
+                    <a:bodyPr/>
                     <a:lstStyle/>
                     <a:p>
                       <a:r>
@@ -12954,7 +13114,7 @@
                 </a:tc>
                 <a:tc>
                   <a:txBody>
-                    <a:bodyPr wrap="square"/>
+                    <a:bodyPr/>
                     <a:lstStyle/>
                     <a:p>
                       <a:r>
@@ -12982,11 +13142,16 @@
                     </a:solidFill>
                   </a:tcPr>
                 </a:tc>
+                <a:extLst>
+                  <a:ext uri="{0D108BD9-81ED-4DB2-BD59-A6C34878D82A}">
+                    <a16:rowId xmlns:a16="http://schemas.microsoft.com/office/drawing/2014/main" val="10001"/>
+                  </a:ext>
+                </a:extLst>
               </a:tr>
-              <a:tr h="457200">
+              <a:tr h="905691">
                 <a:tc>
                   <a:txBody>
-                    <a:bodyPr wrap="square"/>
+                    <a:bodyPr/>
                     <a:lstStyle/>
                     <a:p>
                       <a:r>
@@ -13007,7 +13172,7 @@
                 </a:tc>
                 <a:tc>
                   <a:txBody>
-                    <a:bodyPr wrap="square"/>
+                    <a:bodyPr/>
                     <a:lstStyle/>
                     <a:p>
                       <a:r>
@@ -13037,7 +13202,7 @@
                 </a:tc>
                 <a:tc>
                   <a:txBody>
-                    <a:bodyPr wrap="square"/>
+                    <a:bodyPr/>
                     <a:lstStyle/>
                     <a:p>
                       <a:r>
@@ -13067,7 +13232,7 @@
                 </a:tc>
                 <a:tc>
                   <a:txBody>
-                    <a:bodyPr wrap="square"/>
+                    <a:bodyPr/>
                     <a:lstStyle/>
                     <a:p>
                       <a:r>
@@ -13095,11 +13260,16 @@
                     </a:solidFill>
                   </a:tcPr>
                 </a:tc>
+                <a:extLst>
+                  <a:ext uri="{0D108BD9-81ED-4DB2-BD59-A6C34878D82A}">
+                    <a16:rowId xmlns:a16="http://schemas.microsoft.com/office/drawing/2014/main" val="10002"/>
+                  </a:ext>
+                </a:extLst>
               </a:tr>
-              <a:tr h="457200">
+              <a:tr h="905691">
                 <a:tc>
                   <a:txBody>
-                    <a:bodyPr wrap="square"/>
+                    <a:bodyPr/>
                     <a:lstStyle/>
                     <a:p>
                       <a:r>
@@ -13120,7 +13290,7 @@
                 </a:tc>
                 <a:tc>
                   <a:txBody>
-                    <a:bodyPr wrap="square"/>
+                    <a:bodyPr/>
                     <a:lstStyle/>
                     <a:p>
                       <a:r>
@@ -13150,7 +13320,7 @@
                 </a:tc>
                 <a:tc>
                   <a:txBody>
-                    <a:bodyPr wrap="square"/>
+                    <a:bodyPr/>
                     <a:lstStyle/>
                     <a:p>
                       <a:r>
@@ -13180,11 +13350,11 @@
                 </a:tc>
                 <a:tc>
                   <a:txBody>
-                    <a:bodyPr wrap="square"/>
+                    <a:bodyPr/>
                     <a:lstStyle/>
                     <a:p>
                       <a:r>
-                        <a:rPr sz="1300">
+                        <a:rPr sz="1300" dirty="0">
                           <a:solidFill>
                             <a:srgbClr val="222222"/>
                           </a:solidFill>
@@ -13199,6 +13369,11 @@
                     </a:solidFill>
                   </a:tcPr>
                 </a:tc>
+                <a:extLst>
+                  <a:ext uri="{0D108BD9-81ED-4DB2-BD59-A6C34878D82A}">
+                    <a16:rowId xmlns:a16="http://schemas.microsoft.com/office/drawing/2014/main" val="10003"/>
+                  </a:ext>
+                </a:extLst>
               </a:tr>
             </a:tbl>
           </a:graphicData>
@@ -13566,7 +13741,7 @@
 </file>
 
 <file path=ppt/theme/theme2.xml><?xml version="1.0" encoding="utf-8"?>
-<a:theme xmlns:a="http://schemas.openxmlformats.org/drawingml/2006/main" name="Office Theme">
+<a:theme xmlns:a="http://schemas.openxmlformats.org/drawingml/2006/main" name="Office 테마">
   <a:themeElements>
     <a:clrScheme name="Office">
       <a:dk1>
@@ -13576,44 +13751,44 @@
         <a:sysClr val="window" lastClr="FFFFFF"/>
       </a:lt1>
       <a:dk2>
-        <a:srgbClr val="1F497D"/>
+        <a:srgbClr val="44546A"/>
       </a:dk2>
       <a:lt2>
-        <a:srgbClr val="EEECE1"/>
+        <a:srgbClr val="E7E6E6"/>
       </a:lt2>
       <a:accent1>
-        <a:srgbClr val="4F81BD"/>
+        <a:srgbClr val="4472C4"/>
       </a:accent1>
       <a:accent2>
-        <a:srgbClr val="C0504D"/>
+        <a:srgbClr val="ED7D31"/>
       </a:accent2>
       <a:accent3>
-        <a:srgbClr val="9BBB59"/>
+        <a:srgbClr val="A5A5A5"/>
       </a:accent3>
       <a:accent4>
-        <a:srgbClr val="8064A2"/>
+        <a:srgbClr val="FFC000"/>
       </a:accent4>
       <a:accent5>
-        <a:srgbClr val="4BACC6"/>
+        <a:srgbClr val="5B9BD5"/>
       </a:accent5>
       <a:accent6>
-        <a:srgbClr val="F79646"/>
+        <a:srgbClr val="70AD47"/>
       </a:accent6>
       <a:hlink>
-        <a:srgbClr val="0000FF"/>
+        <a:srgbClr val="0563C1"/>
       </a:hlink>
       <a:folHlink>
-        <a:srgbClr val="800080"/>
+        <a:srgbClr val="954F72"/>
       </a:folHlink>
     </a:clrScheme>
     <a:fontScheme name="Office">
       <a:majorFont>
-        <a:latin typeface="Calibri"/>
+        <a:latin typeface="맑은 고딕" panose="020F0302020204030204"/>
         <a:ea typeface=""/>
         <a:cs typeface=""/>
-        <a:font script="Jpan" typeface="ＭＳ Ｐゴシック"/>
+        <a:font script="Jpan" typeface="游ゴシック Light"/>
         <a:font script="Hang" typeface="맑은 고딕"/>
-        <a:font script="Hans" typeface="宋体"/>
+        <a:font script="Hans" typeface="等线 Light"/>
         <a:font script="Hant" typeface="新細明體"/>
         <a:font script="Arab" typeface="Times New Roman"/>
         <a:font script="Hebr" typeface="Times New Roman"/>
@@ -13641,14 +13816,31 @@
         <a:font script="Viet" typeface="Times New Roman"/>
         <a:font script="Uigh" typeface="Microsoft Uighur"/>
         <a:font script="Geor" typeface="Sylfaen"/>
+        <a:font script="Armn" typeface="Arial"/>
+        <a:font script="Bugi" typeface="Leelawadee UI"/>
+        <a:font script="Bopo" typeface="Microsoft JhengHei"/>
+        <a:font script="Java" typeface="Javanese Text"/>
+        <a:font script="Lisu" typeface="Segoe UI"/>
+        <a:font script="Mymr" typeface="Myanmar Text"/>
+        <a:font script="Nkoo" typeface="Ebrima"/>
+        <a:font script="Olck" typeface="Nirmala UI"/>
+        <a:font script="Osma" typeface="Ebrima"/>
+        <a:font script="Phag" typeface="Phagspa"/>
+        <a:font script="Syrn" typeface="Estrangelo Edessa"/>
+        <a:font script="Syrj" typeface="Estrangelo Edessa"/>
+        <a:font script="Syre" typeface="Estrangelo Edessa"/>
+        <a:font script="Sora" typeface="Nirmala UI"/>
+        <a:font script="Tale" typeface="Microsoft Tai Le"/>
+        <a:font script="Talu" typeface="Microsoft New Tai Lue"/>
+        <a:font script="Tfng" typeface="Ebrima"/>
       </a:majorFont>
       <a:minorFont>
-        <a:latin typeface="Calibri"/>
+        <a:latin typeface="맑은 고딕" panose="020F0502020204030204"/>
         <a:ea typeface=""/>
         <a:cs typeface=""/>
-        <a:font script="Jpan" typeface="ＭＳ Ｐゴシック"/>
+        <a:font script="Jpan" typeface="游ゴシック"/>
         <a:font script="Hang" typeface="맑은 고딕"/>
-        <a:font script="Hans" typeface="宋体"/>
+        <a:font script="Hans" typeface="等线"/>
         <a:font script="Hant" typeface="新細明體"/>
         <a:font script="Arab" typeface="Arial"/>
         <a:font script="Hebr" typeface="Arial"/>
@@ -13676,6 +13868,23 @@
         <a:font script="Viet" typeface="Arial"/>
         <a:font script="Uigh" typeface="Microsoft Uighur"/>
         <a:font script="Geor" typeface="Sylfaen"/>
+        <a:font script="Armn" typeface="Arial"/>
+        <a:font script="Bugi" typeface="Leelawadee UI"/>
+        <a:font script="Bopo" typeface="Microsoft JhengHei"/>
+        <a:font script="Java" typeface="Javanese Text"/>
+        <a:font script="Lisu" typeface="Segoe UI"/>
+        <a:font script="Mymr" typeface="Myanmar Text"/>
+        <a:font script="Nkoo" typeface="Ebrima"/>
+        <a:font script="Olck" typeface="Nirmala UI"/>
+        <a:font script="Osma" typeface="Ebrima"/>
+        <a:font script="Phag" typeface="Phagspa"/>
+        <a:font script="Syrn" typeface="Estrangelo Edessa"/>
+        <a:font script="Syrj" typeface="Estrangelo Edessa"/>
+        <a:font script="Syre" typeface="Estrangelo Edessa"/>
+        <a:font script="Sora" typeface="Nirmala UI"/>
+        <a:font script="Tale" typeface="Microsoft Tai Le"/>
+        <a:font script="Talu" typeface="Microsoft New Tai Lue"/>
+        <a:font script="Tfng" typeface="Ebrima"/>
       </a:minorFont>
     </a:fontScheme>
     <a:fmtScheme name="Office">
@@ -13687,200 +13896,141 @@
           <a:gsLst>
             <a:gs pos="0">
               <a:schemeClr val="phClr">
-                <a:tint val="50000"/>
-                <a:satMod val="300000"/>
+                <a:lumMod val="110000"/>
+                <a:satMod val="105000"/>
+                <a:tint val="67000"/>
               </a:schemeClr>
             </a:gs>
-            <a:gs pos="35000">
+            <a:gs pos="50000">
               <a:schemeClr val="phClr">
-                <a:tint val="37000"/>
-                <a:satMod val="300000"/>
+                <a:lumMod val="105000"/>
+                <a:satMod val="103000"/>
+                <a:tint val="73000"/>
               </a:schemeClr>
             </a:gs>
             <a:gs pos="100000">
               <a:schemeClr val="phClr">
-                <a:tint val="15000"/>
-                <a:satMod val="350000"/>
+                <a:lumMod val="105000"/>
+                <a:satMod val="109000"/>
+                <a:tint val="81000"/>
               </a:schemeClr>
             </a:gs>
           </a:gsLst>
-          <a:lin ang="16200000" scaled="1"/>
+          <a:lin ang="5400000" scaled="0"/>
         </a:gradFill>
         <a:gradFill rotWithShape="1">
           <a:gsLst>
             <a:gs pos="0">
               <a:schemeClr val="phClr">
-                <a:tint val="100000"/>
+                <a:satMod val="103000"/>
+                <a:lumMod val="102000"/>
+                <a:tint val="94000"/>
+              </a:schemeClr>
+            </a:gs>
+            <a:gs pos="50000">
+              <a:schemeClr val="phClr">
+                <a:satMod val="110000"/>
+                <a:lumMod val="100000"/>
                 <a:shade val="100000"/>
-                <a:satMod val="130000"/>
               </a:schemeClr>
             </a:gs>
             <a:gs pos="100000">
               <a:schemeClr val="phClr">
-                <a:tint val="50000"/>
-                <a:shade val="100000"/>
-                <a:satMod val="350000"/>
+                <a:lumMod val="99000"/>
+                <a:satMod val="120000"/>
+                <a:shade val="78000"/>
               </a:schemeClr>
             </a:gs>
           </a:gsLst>
-          <a:lin ang="16200000" scaled="0"/>
+          <a:lin ang="5400000" scaled="0"/>
         </a:gradFill>
       </a:fillStyleLst>
       <a:lnStyleLst>
-        <a:ln w="9525" cap="flat" cmpd="sng" algn="ctr">
-          <a:solidFill>
-            <a:schemeClr val="phClr">
-              <a:shade val="95000"/>
-              <a:satMod val="105000"/>
-            </a:schemeClr>
-          </a:solidFill>
-          <a:prstDash val="solid"/>
-        </a:ln>
-        <a:ln w="25400" cap="flat" cmpd="sng" algn="ctr">
+        <a:ln w="6350" cap="flat" cmpd="sng" algn="ctr">
           <a:solidFill>
             <a:schemeClr val="phClr"/>
           </a:solidFill>
           <a:prstDash val="solid"/>
+          <a:miter lim="800000"/>
         </a:ln>
-        <a:ln w="38100" cap="flat" cmpd="sng" algn="ctr">
+        <a:ln w="12700" cap="flat" cmpd="sng" algn="ctr">
           <a:solidFill>
             <a:schemeClr val="phClr"/>
           </a:solidFill>
           <a:prstDash val="solid"/>
+          <a:miter lim="800000"/>
+        </a:ln>
+        <a:ln w="19050" cap="flat" cmpd="sng" algn="ctr">
+          <a:solidFill>
+            <a:schemeClr val="phClr"/>
+          </a:solidFill>
+          <a:prstDash val="solid"/>
+          <a:miter lim="800000"/>
         </a:ln>
       </a:lnStyleLst>
       <a:effectStyleLst>
         <a:effectStyle>
+          <a:effectLst/>
+        </a:effectStyle>
+        <a:effectStyle>
+          <a:effectLst/>
+        </a:effectStyle>
+        <a:effectStyle>
           <a:effectLst>
-            <a:outerShdw blurRad="40000" dist="20000" dir="5400000" rotWithShape="0">
+            <a:outerShdw blurRad="57150" dist="19050" dir="5400000" algn="ctr" rotWithShape="0">
               <a:srgbClr val="000000">
-                <a:alpha val="38000"/>
+                <a:alpha val="63000"/>
               </a:srgbClr>
             </a:outerShdw>
           </a:effectLst>
-        </a:effectStyle>
-        <a:effectStyle>
-          <a:effectLst>
-            <a:outerShdw blurRad="40000" dist="23000" dir="5400000" rotWithShape="0">
-              <a:srgbClr val="000000">
-                <a:alpha val="35000"/>
-              </a:srgbClr>
-            </a:outerShdw>
-          </a:effectLst>
-        </a:effectStyle>
-        <a:effectStyle>
-          <a:effectLst>
-            <a:outerShdw blurRad="40000" dist="23000" dir="5400000" rotWithShape="0">
-              <a:srgbClr val="000000">
-                <a:alpha val="35000"/>
-              </a:srgbClr>
-            </a:outerShdw>
-          </a:effectLst>
-          <a:scene3d>
-            <a:camera prst="orthographicFront">
-              <a:rot lat="0" lon="0" rev="0"/>
-            </a:camera>
-            <a:lightRig rig="threePt" dir="t">
-              <a:rot lat="0" lon="0" rev="1200000"/>
-            </a:lightRig>
-          </a:scene3d>
-          <a:sp3d>
-            <a:bevelT w="63500" h="25400"/>
-          </a:sp3d>
         </a:effectStyle>
       </a:effectStyleLst>
       <a:bgFillStyleLst>
         <a:solidFill>
           <a:schemeClr val="phClr"/>
         </a:solidFill>
+        <a:solidFill>
+          <a:schemeClr val="phClr">
+            <a:tint val="95000"/>
+            <a:satMod val="170000"/>
+          </a:schemeClr>
+        </a:solidFill>
         <a:gradFill rotWithShape="1">
           <a:gsLst>
             <a:gs pos="0">
               <a:schemeClr val="phClr">
-                <a:tint val="40000"/>
-                <a:satMod val="350000"/>
+                <a:tint val="93000"/>
+                <a:satMod val="150000"/>
+                <a:shade val="98000"/>
+                <a:lumMod val="102000"/>
               </a:schemeClr>
             </a:gs>
-            <a:gs pos="40000">
+            <a:gs pos="50000">
               <a:schemeClr val="phClr">
-                <a:tint val="45000"/>
-                <a:shade val="99000"/>
-                <a:satMod val="350000"/>
+                <a:tint val="98000"/>
+                <a:satMod val="130000"/>
+                <a:shade val="90000"/>
+                <a:lumMod val="103000"/>
               </a:schemeClr>
             </a:gs>
             <a:gs pos="100000">
               <a:schemeClr val="phClr">
-                <a:shade val="20000"/>
-                <a:satMod val="255000"/>
+                <a:shade val="63000"/>
+                <a:satMod val="120000"/>
               </a:schemeClr>
             </a:gs>
           </a:gsLst>
-          <a:path path="circle">
-            <a:fillToRect l="50000" t="-80000" r="50000" b="180000"/>
-          </a:path>
-        </a:gradFill>
-        <a:gradFill rotWithShape="1">
-          <a:gsLst>
-            <a:gs pos="0">
-              <a:schemeClr val="phClr">
-                <a:tint val="80000"/>
-                <a:satMod val="300000"/>
-              </a:schemeClr>
-            </a:gs>
-            <a:gs pos="100000">
-              <a:schemeClr val="phClr">
-                <a:shade val="30000"/>
-                <a:satMod val="200000"/>
-              </a:schemeClr>
-            </a:gs>
-          </a:gsLst>
-          <a:path path="circle">
-            <a:fillToRect l="50000" t="50000" r="50000" b="50000"/>
-          </a:path>
+          <a:lin ang="5400000" scaled="0"/>
         </a:gradFill>
       </a:bgFillStyleLst>
     </a:fmtScheme>
   </a:themeElements>
-  <a:objectDefaults>
-    <a:spDef>
-      <a:spPr/>
-      <a:bodyPr/>
-      <a:lstStyle/>
-      <a:style>
-        <a:lnRef idx="1">
-          <a:schemeClr val="accent1"/>
-        </a:lnRef>
-        <a:fillRef idx="3">
-          <a:schemeClr val="accent1"/>
-        </a:fillRef>
-        <a:effectRef idx="2">
-          <a:schemeClr val="accent1"/>
-        </a:effectRef>
-        <a:fontRef idx="minor">
-          <a:schemeClr val="lt1"/>
-        </a:fontRef>
-      </a:style>
-    </a:spDef>
-    <a:lnDef>
-      <a:spPr/>
-      <a:bodyPr/>
-      <a:lstStyle/>
-      <a:style>
-        <a:lnRef idx="2">
-          <a:schemeClr val="accent1"/>
-        </a:lnRef>
-        <a:fillRef idx="0">
-          <a:schemeClr val="accent1"/>
-        </a:fillRef>
-        <a:effectRef idx="1">
-          <a:schemeClr val="accent1"/>
-        </a:effectRef>
-        <a:fontRef idx="minor">
-          <a:schemeClr val="tx1"/>
-        </a:fontRef>
-      </a:style>
-    </a:lnDef>
-  </a:objectDefaults>
+  <a:objectDefaults/>
   <a:extraClrSchemeLst/>
+  <a:extLst>
+    <a:ext uri="{05A4C25C-085E-4340-85A3-A5531E510DB2}">
+      <thm15:themeFamily xmlns:thm15="http://schemas.microsoft.com/office/thememl/2012/main" name="Office Theme" id="{62F939B6-93AF-4DB8-9C6B-D6C7DFDC589F}" vid="{4A3C46E8-61CC-4603-A589-7422A47A8E4A}"/>
+    </a:ext>
+  </a:extLst>
 </a:theme>
 </file>
</xml_diff>